<commit_message>
docs(presentation): embed live product screenshots in the jury deck
Slides 5/6/9 now show the real product: POS with an in-stock cart line, the billing portal with the Card/M-PESA rail toggle (usage meters cropped out), and the dashboard with real org data. shoot-deck.mjs probes every branch x warehouse combo to frame the best POS shot, adds an item to the cart, and anchors CHANGE PLAN below the sticky header so the red over-limit meters never reach the deck.
</commit_message>
<xml_diff>
--- a/docs/presentation/KaziOS-Presentation.pptx
+++ b/docs/presentation/KaziOS-Presentation.pptx
@@ -22,8 +22,8 @@
   <p:notesMasterIdLst>
     <p:notesMasterId r:id="rId15"/>
   </p:notesMasterIdLst>
-  <p:sldSz cx="9144000" cy="5143500"/>
-  <p:notesSz cx="5143500" cy="9144000"/>
+  <p:sldSz cx="12192000" cy="6858000"/>
+  <p:notesSz cx="6858000" cy="12192000"/>
   <p:defaultTextStyle>
     <a:lvl1pPr marL="0" algn="l" defTabSz="914400" rtl="0" eaLnBrk="1" latinLnBrk="0" hangingPunct="1">
       <a:defRPr sz="1800" kern="1200">
@@ -1306,7 +1306,7 @@
           <a:p>
             <a:r>
               <a:rPr lang="en-US" dirty="0"/>
-              <a:t>Two rails, one engine. The M-PESA side is the story: Daraja STK Push, server-side re-query as the only source of truth, idempotency and amount checks — payments engineering, not a button.</a:t>
+              <a:t>Two rails, one engine. The M-PESA side is the story: Daraja STK Push, server-side re-query as the only source of truth, idempotency and amount checks — payments engineering, not a button. The screenshot is the live billing portal with the Card/M-PESA rail toggle. Full trust list also covers: free plan and paid plans, monthly or annual, run on one engine; the billing portal issues invoices, receipts and plan changes.</a:t>
             </a:r>
             <a:endParaRPr lang="en-US" dirty="0"/>
           </a:p>
@@ -7626,7 +7626,7 @@
         <p:spPr>
           <a:xfrm>
             <a:off x="6492240" y="1810512"/>
-            <a:ext cx="2834640" cy="621792"/>
+            <a:ext cx="5138928" cy="621792"/>
           </a:xfrm>
           <a:prstGeom prst="roundRect">
             <a:avLst>
@@ -7673,7 +7673,7 @@
         <p:spPr>
           <a:xfrm>
             <a:off x="6995160" y="1810512"/>
-            <a:ext cx="2194560" cy="621792"/>
+            <a:ext cx="4498848" cy="621792"/>
           </a:xfrm>
           <a:prstGeom prst="rect">
             <a:avLst/>
@@ -7712,7 +7712,7 @@
         <p:spPr>
           <a:xfrm>
             <a:off x="6492240" y="2596896"/>
-            <a:ext cx="2834640" cy="621792"/>
+            <a:ext cx="5138928" cy="621792"/>
           </a:xfrm>
           <a:prstGeom prst="roundRect">
             <a:avLst>
@@ -7759,7 +7759,7 @@
         <p:spPr>
           <a:xfrm>
             <a:off x="6995160" y="2596896"/>
-            <a:ext cx="2194560" cy="621792"/>
+            <a:ext cx="4498848" cy="621792"/>
           </a:xfrm>
           <a:prstGeom prst="rect">
             <a:avLst/>
@@ -7798,7 +7798,7 @@
         <p:spPr>
           <a:xfrm>
             <a:off x="6492240" y="3383280"/>
-            <a:ext cx="2834640" cy="621792"/>
+            <a:ext cx="5138928" cy="621792"/>
           </a:xfrm>
           <a:prstGeom prst="roundRect">
             <a:avLst>
@@ -7845,7 +7845,7 @@
         <p:spPr>
           <a:xfrm>
             <a:off x="6995160" y="3383280"/>
-            <a:ext cx="2194560" cy="621792"/>
+            <a:ext cx="4498848" cy="621792"/>
           </a:xfrm>
           <a:prstGeom prst="rect">
             <a:avLst/>
@@ -7884,7 +7884,7 @@
         <p:spPr>
           <a:xfrm>
             <a:off x="6492240" y="4169664"/>
-            <a:ext cx="2834640" cy="621792"/>
+            <a:ext cx="5138928" cy="621792"/>
           </a:xfrm>
           <a:prstGeom prst="roundRect">
             <a:avLst>
@@ -7931,7 +7931,7 @@
         <p:spPr>
           <a:xfrm>
             <a:off x="6995160" y="4169664"/>
-            <a:ext cx="2194560" cy="621792"/>
+            <a:ext cx="4498848" cy="621792"/>
           </a:xfrm>
           <a:prstGeom prst="rect">
             <a:avLst/>
@@ -7970,7 +7970,7 @@
         <p:spPr>
           <a:xfrm>
             <a:off x="6492240" y="4956048"/>
-            <a:ext cx="2834640" cy="621792"/>
+            <a:ext cx="5138928" cy="621792"/>
           </a:xfrm>
           <a:prstGeom prst="roundRect">
             <a:avLst>
@@ -8017,7 +8017,7 @@
         <p:spPr>
           <a:xfrm>
             <a:off x="6995160" y="4956048"/>
-            <a:ext cx="2194560" cy="621792"/>
+            <a:ext cx="4498848" cy="621792"/>
           </a:xfrm>
           <a:prstGeom prst="rect">
             <a:avLst/>
@@ -8056,7 +8056,7 @@
         <p:spPr>
           <a:xfrm>
             <a:off x="6492240" y="5742432"/>
-            <a:ext cx="2834640" cy="621792"/>
+            <a:ext cx="5138928" cy="621792"/>
           </a:xfrm>
           <a:prstGeom prst="roundRect">
             <a:avLst>
@@ -8103,7 +8103,7 @@
         <p:spPr>
           <a:xfrm>
             <a:off x="6995160" y="5742432"/>
-            <a:ext cx="2194560" cy="621792"/>
+            <a:ext cx="4498848" cy="621792"/>
           </a:xfrm>
           <a:prstGeom prst="rect">
             <a:avLst/>
@@ -8488,16 +8488,16 @@
         </p:nvSpPr>
         <p:spPr>
           <a:xfrm>
-            <a:off x="502920" y="1645920"/>
-            <a:ext cx="2651760" cy="1920240"/>
+            <a:off x="457200" y="1600200"/>
+            <a:ext cx="5669280" cy="3577590"/>
           </a:xfrm>
           <a:prstGeom prst="roundRect">
             <a:avLst>
-              <a:gd name="adj" fmla="val 4286"/>
+              <a:gd name="adj" fmla="val 2300"/>
             </a:avLst>
           </a:prstGeom>
           <a:solidFill>
-            <a:srgbClr val="0C1F40"/>
+            <a:srgbClr val="102542"/>
           </a:solidFill>
           <a:ln w="12700">
             <a:solidFill>
@@ -8507,118 +8507,83 @@
           </a:ln>
         </p:spPr>
       </p:sp>
-      <p:sp>
-        <p:nvSpPr>
-          <p:cNvPr id="7" name="Shape 5"/>
-          <p:cNvSpPr/>
-          <p:nvPr/>
-        </p:nvSpPr>
-        <p:spPr>
-          <a:xfrm>
-            <a:off x="704088" y="1865376"/>
-            <a:ext cx="457200" cy="64008"/>
-          </a:xfrm>
-          <a:prstGeom prst="rect">
-            <a:avLst/>
-          </a:prstGeom>
-          <a:solidFill>
-            <a:srgbClr val="F5A314"/>
-          </a:solidFill>
-          <a:ln/>
-        </p:spPr>
-      </p:sp>
-      <p:sp>
-        <p:nvSpPr>
-          <p:cNvPr id="8" name="Text 6"/>
-          <p:cNvSpPr/>
-          <p:nvPr/>
-        </p:nvSpPr>
-        <p:spPr>
-          <a:xfrm>
-            <a:off x="704088" y="2011680"/>
-            <a:ext cx="2249424" cy="566928"/>
-          </a:xfrm>
-          <a:prstGeom prst="rect">
-            <a:avLst/>
-          </a:prstGeom>
-          <a:noFill/>
-          <a:ln/>
-        </p:spPr>
-        <p:txBody>
-          <a:bodyPr wrap="square" rtlCol="0" anchor="t"/>
+      <p:pic>
+        <p:nvPicPr>
+          <p:cNvPr id="7" name="Image 0" descr="C:/Users/ZBOOK/AppData/Local/Temp/kazi-deck/assets/shot-pos.png">    </p:cNvPr>
+          <p:cNvPicPr>
+            <a:picLocks noChangeAspect="1"/>
+          </p:cNvPicPr>
+          <p:nvPr/>
+        </p:nvPicPr>
+        <p:blipFill>
+          <a:blip r:embed="rId1"/>
+          <a:stretch>
+            <a:fillRect/>
+          </a:stretch>
+        </p:blipFill>
+        <p:spPr>
+          <a:xfrm>
+            <a:off x="502920" y="1645920"/>
+            <a:ext cx="5577840" cy="3486150"/>
+          </a:xfrm>
+          <a:prstGeom prst="rect">
+            <a:avLst/>
+          </a:prstGeom>
+        </p:spPr>
+      </p:pic>
+      <p:sp>
+        <p:nvSpPr>
+          <p:cNvPr id="8" name="Text 5"/>
+          <p:cNvSpPr/>
+          <p:nvPr/>
+        </p:nvSpPr>
+        <p:spPr>
+          <a:xfrm>
+            <a:off x="502920" y="5241798"/>
+            <a:ext cx="5577840" cy="274320"/>
+          </a:xfrm>
+          <a:prstGeom prst="rect">
+            <a:avLst/>
+          </a:prstGeom>
+          <a:noFill/>
+          <a:ln/>
+        </p:spPr>
+        <p:txBody>
+          <a:bodyPr wrap="square" rtlCol="0" anchor="ctr"/>
           <a:lstStyle/>
           <a:p>
             <a:pPr indent="0" marL="0">
               <a:buNone/>
             </a:pPr>
             <a:r>
-              <a:rPr lang="en-US" sz="1450" b="1" dirty="0">
-                <a:solidFill>
-                  <a:srgbClr val="F5F0E6"/>
-                </a:solidFill>
-                <a:latin typeface="Calibri" pitchFamily="34" charset="0"/>
-                <a:ea typeface="Calibri" pitchFamily="34" charset="-122"/>
-                <a:cs typeface="Calibri" pitchFamily="34" charset="-120"/>
-              </a:rPr>
-              <a:t>Point of Sale</a:t>
-            </a:r>
-            <a:endParaRPr lang="en-US" sz="1450" dirty="0"/>
-          </a:p>
-        </p:txBody>
-      </p:sp>
-      <p:sp>
-        <p:nvSpPr>
-          <p:cNvPr id="9" name="Text 7"/>
-          <p:cNvSpPr/>
-          <p:nvPr/>
-        </p:nvSpPr>
-        <p:spPr>
-          <a:xfrm>
-            <a:off x="704088" y="2560320"/>
-            <a:ext cx="2249424" cy="896112"/>
-          </a:xfrm>
-          <a:prstGeom prst="rect">
-            <a:avLst/>
-          </a:prstGeom>
-          <a:noFill/>
-          <a:ln/>
-        </p:spPr>
-        <p:txBody>
-          <a:bodyPr wrap="square" rtlCol="0" anchor="t"/>
-          <a:lstStyle/>
-          <a:p>
-            <a:pPr indent="0" marL="0">
-              <a:buNone/>
-            </a:pPr>
-            <a:r>
-              <a:rPr lang="en-US" sz="1150" dirty="0">
-                <a:solidFill>
-                  <a:srgbClr val="C7D2E4"/>
-                </a:solidFill>
-                <a:latin typeface="Calibri" pitchFamily="34" charset="0"/>
-                <a:ea typeface="Calibri" pitchFamily="34" charset="-122"/>
-                <a:cs typeface="Calibri" pitchFamily="34" charset="-120"/>
-              </a:rPr>
-              <a:t>Search, cart, discounts, tax, receipts and cashier workflows.</a:t>
-            </a:r>
-            <a:endParaRPr lang="en-US" sz="1150" dirty="0"/>
-          </a:p>
-        </p:txBody>
-      </p:sp>
-      <p:sp>
-        <p:nvSpPr>
-          <p:cNvPr id="10" name="Shape 8"/>
-          <p:cNvSpPr/>
-          <p:nvPr/>
-        </p:nvSpPr>
-        <p:spPr>
-          <a:xfrm>
-            <a:off x="3328416" y="1645920"/>
-            <a:ext cx="2651760" cy="1920240"/>
+              <a:rPr lang="en-US" sz="1100" i="1" dirty="0">
+                <a:solidFill>
+                  <a:srgbClr val="8FA0BC"/>
+                </a:solidFill>
+                <a:latin typeface="Calibri" pitchFamily="34" charset="0"/>
+                <a:ea typeface="Calibri" pitchFamily="34" charset="-122"/>
+                <a:cs typeface="Calibri" pitchFamily="34" charset="-120"/>
+              </a:rPr>
+              <a:t>Live POS — branch, warehouse and category filters in one screen.</a:t>
+            </a:r>
+            <a:endParaRPr lang="en-US" sz="1100" dirty="0"/>
+          </a:p>
+        </p:txBody>
+      </p:sp>
+      <p:sp>
+        <p:nvSpPr>
+          <p:cNvPr id="9" name="Shape 6"/>
+          <p:cNvSpPr/>
+          <p:nvPr/>
+        </p:nvSpPr>
+        <p:spPr>
+          <a:xfrm>
+            <a:off x="6400800" y="1645920"/>
+            <a:ext cx="2523744" cy="873252"/>
           </a:xfrm>
           <a:prstGeom prst="roundRect">
             <a:avLst>
-              <a:gd name="adj" fmla="val 4286"/>
+              <a:gd name="adj" fmla="val 9424"/>
             </a:avLst>
           </a:prstGeom>
           <a:solidFill>
@@ -8634,34 +8599,73 @@
       </p:sp>
       <p:sp>
         <p:nvSpPr>
-          <p:cNvPr id="11" name="Shape 9"/>
-          <p:cNvSpPr/>
-          <p:nvPr/>
-        </p:nvSpPr>
-        <p:spPr>
-          <a:xfrm>
-            <a:off x="3529584" y="1865376"/>
-            <a:ext cx="457200" cy="64008"/>
-          </a:xfrm>
-          <a:prstGeom prst="rect">
-            <a:avLst/>
-          </a:prstGeom>
-          <a:solidFill>
-            <a:srgbClr val="0E9488"/>
-          </a:solidFill>
-          <a:ln/>
-        </p:spPr>
-      </p:sp>
-      <p:sp>
-        <p:nvSpPr>
-          <p:cNvPr id="12" name="Text 10"/>
-          <p:cNvSpPr/>
-          <p:nvPr/>
-        </p:nvSpPr>
-        <p:spPr>
-          <a:xfrm>
-            <a:off x="3529584" y="2011680"/>
-            <a:ext cx="2249424" cy="566928"/>
+          <p:cNvPr id="10" name="Shape 7"/>
+          <p:cNvSpPr/>
+          <p:nvPr/>
+        </p:nvSpPr>
+        <p:spPr>
+          <a:xfrm>
+            <a:off x="6565392" y="1792224"/>
+            <a:ext cx="384048" cy="50292"/>
+          </a:xfrm>
+          <a:prstGeom prst="rect">
+            <a:avLst/>
+          </a:prstGeom>
+          <a:solidFill>
+            <a:srgbClr val="F5A314"/>
+          </a:solidFill>
+          <a:ln/>
+        </p:spPr>
+      </p:sp>
+      <p:sp>
+        <p:nvSpPr>
+          <p:cNvPr id="11" name="Text 8"/>
+          <p:cNvSpPr/>
+          <p:nvPr/>
+        </p:nvSpPr>
+        <p:spPr>
+          <a:xfrm>
+            <a:off x="6565392" y="1883664"/>
+            <a:ext cx="2194560" cy="237744"/>
+          </a:xfrm>
+          <a:prstGeom prst="rect">
+            <a:avLst/>
+          </a:prstGeom>
+          <a:noFill/>
+          <a:ln/>
+        </p:spPr>
+        <p:txBody>
+          <a:bodyPr wrap="square" rtlCol="0" anchor="ctr"/>
+          <a:lstStyle/>
+          <a:p>
+            <a:pPr indent="0" marL="0">
+              <a:buNone/>
+            </a:pPr>
+            <a:r>
+              <a:rPr lang="en-US" sz="1200" b="1" dirty="0">
+                <a:solidFill>
+                  <a:srgbClr val="F5F0E6"/>
+                </a:solidFill>
+                <a:latin typeface="Calibri" pitchFamily="34" charset="0"/>
+                <a:ea typeface="Calibri" pitchFamily="34" charset="-122"/>
+                <a:cs typeface="Calibri" pitchFamily="34" charset="-120"/>
+              </a:rPr>
+              <a:t>Point of Sale</a:t>
+            </a:r>
+            <a:endParaRPr lang="en-US" sz="1200" dirty="0"/>
+          </a:p>
+        </p:txBody>
+      </p:sp>
+      <p:sp>
+        <p:nvSpPr>
+          <p:cNvPr id="12" name="Text 9"/>
+          <p:cNvSpPr/>
+          <p:nvPr/>
+        </p:nvSpPr>
+        <p:spPr>
+          <a:xfrm>
+            <a:off x="6565392" y="2130552"/>
+            <a:ext cx="2194560" cy="365760"/>
           </a:xfrm>
           <a:prstGeom prst="rect">
             <a:avLst/>
@@ -8677,46 +8681,7 @@
               <a:buNone/>
             </a:pPr>
             <a:r>
-              <a:rPr lang="en-US" sz="1450" b="1" dirty="0">
-                <a:solidFill>
-                  <a:srgbClr val="F5F0E6"/>
-                </a:solidFill>
-                <a:latin typeface="Calibri" pitchFamily="34" charset="0"/>
-                <a:ea typeface="Calibri" pitchFamily="34" charset="-122"/>
-                <a:cs typeface="Calibri" pitchFamily="34" charset="-120"/>
-              </a:rPr>
-              <a:t>Products &amp; Inventory</a:t>
-            </a:r>
-            <a:endParaRPr lang="en-US" sz="1450" dirty="0"/>
-          </a:p>
-        </p:txBody>
-      </p:sp>
-      <p:sp>
-        <p:nvSpPr>
-          <p:cNvPr id="13" name="Text 11"/>
-          <p:cNvSpPr/>
-          <p:nvPr/>
-        </p:nvSpPr>
-        <p:spPr>
-          <a:xfrm>
-            <a:off x="3529584" y="2560320"/>
-            <a:ext cx="2249424" cy="896112"/>
-          </a:xfrm>
-          <a:prstGeom prst="rect">
-            <a:avLst/>
-          </a:prstGeom>
-          <a:noFill/>
-          <a:ln/>
-        </p:spPr>
-        <p:txBody>
-          <a:bodyPr wrap="square" rtlCol="0" anchor="t"/>
-          <a:lstStyle/>
-          <a:p>
-            <a:pPr indent="0" marL="0">
-              <a:buNone/>
-            </a:pPr>
-            <a:r>
-              <a:rPr lang="en-US" sz="1150" dirty="0">
+              <a:rPr lang="en-US" sz="900" dirty="0">
                 <a:solidFill>
                   <a:srgbClr val="C7D2E4"/>
                 </a:solidFill>
@@ -8724,26 +8689,26 @@
                 <a:ea typeface="Calibri" pitchFamily="34" charset="-122"/>
                 <a:cs typeface="Calibri" pitchFamily="34" charset="-120"/>
               </a:rPr>
-              <a:t>SKUs, barcodes, categories, warehouses and stock movements.</a:t>
-            </a:r>
-            <a:endParaRPr lang="en-US" sz="1150" dirty="0"/>
-          </a:p>
-        </p:txBody>
-      </p:sp>
-      <p:sp>
-        <p:nvSpPr>
-          <p:cNvPr id="14" name="Shape 12"/>
-          <p:cNvSpPr/>
-          <p:nvPr/>
-        </p:nvSpPr>
-        <p:spPr>
-          <a:xfrm>
-            <a:off x="6153912" y="1645920"/>
-            <a:ext cx="2651760" cy="1920240"/>
+              <a:t>Search, cart, discounts, tax, receipts and cashier workflows.</a:t>
+            </a:r>
+            <a:endParaRPr lang="en-US" sz="900" dirty="0"/>
+          </a:p>
+        </p:txBody>
+      </p:sp>
+      <p:sp>
+        <p:nvSpPr>
+          <p:cNvPr id="13" name="Shape 10"/>
+          <p:cNvSpPr/>
+          <p:nvPr/>
+        </p:nvSpPr>
+        <p:spPr>
+          <a:xfrm>
+            <a:off x="9107424" y="1645920"/>
+            <a:ext cx="2523744" cy="873252"/>
           </a:xfrm>
           <a:prstGeom prst="roundRect">
             <a:avLst>
-              <a:gd name="adj" fmla="val 4286"/>
+              <a:gd name="adj" fmla="val 9424"/>
             </a:avLst>
           </a:prstGeom>
           <a:solidFill>
@@ -8759,34 +8724,73 @@
       </p:sp>
       <p:sp>
         <p:nvSpPr>
-          <p:cNvPr id="15" name="Shape 13"/>
-          <p:cNvSpPr/>
-          <p:nvPr/>
-        </p:nvSpPr>
-        <p:spPr>
-          <a:xfrm>
-            <a:off x="6355080" y="1865376"/>
-            <a:ext cx="457200" cy="64008"/>
-          </a:xfrm>
-          <a:prstGeom prst="rect">
-            <a:avLst/>
-          </a:prstGeom>
-          <a:solidFill>
-            <a:srgbClr val="F5A314"/>
-          </a:solidFill>
-          <a:ln/>
-        </p:spPr>
-      </p:sp>
-      <p:sp>
-        <p:nvSpPr>
-          <p:cNvPr id="16" name="Text 14"/>
-          <p:cNvSpPr/>
-          <p:nvPr/>
-        </p:nvSpPr>
-        <p:spPr>
-          <a:xfrm>
-            <a:off x="6355080" y="2011680"/>
-            <a:ext cx="2249424" cy="566928"/>
+          <p:cNvPr id="14" name="Shape 11"/>
+          <p:cNvSpPr/>
+          <p:nvPr/>
+        </p:nvSpPr>
+        <p:spPr>
+          <a:xfrm>
+            <a:off x="9272016" y="1792224"/>
+            <a:ext cx="384048" cy="50292"/>
+          </a:xfrm>
+          <a:prstGeom prst="rect">
+            <a:avLst/>
+          </a:prstGeom>
+          <a:solidFill>
+            <a:srgbClr val="0E9488"/>
+          </a:solidFill>
+          <a:ln/>
+        </p:spPr>
+      </p:sp>
+      <p:sp>
+        <p:nvSpPr>
+          <p:cNvPr id="15" name="Text 12"/>
+          <p:cNvSpPr/>
+          <p:nvPr/>
+        </p:nvSpPr>
+        <p:spPr>
+          <a:xfrm>
+            <a:off x="9272016" y="1883664"/>
+            <a:ext cx="2194560" cy="237744"/>
+          </a:xfrm>
+          <a:prstGeom prst="rect">
+            <a:avLst/>
+          </a:prstGeom>
+          <a:noFill/>
+          <a:ln/>
+        </p:spPr>
+        <p:txBody>
+          <a:bodyPr wrap="square" rtlCol="0" anchor="ctr"/>
+          <a:lstStyle/>
+          <a:p>
+            <a:pPr indent="0" marL="0">
+              <a:buNone/>
+            </a:pPr>
+            <a:r>
+              <a:rPr lang="en-US" sz="1200" b="1" dirty="0">
+                <a:solidFill>
+                  <a:srgbClr val="F5F0E6"/>
+                </a:solidFill>
+                <a:latin typeface="Calibri" pitchFamily="34" charset="0"/>
+                <a:ea typeface="Calibri" pitchFamily="34" charset="-122"/>
+                <a:cs typeface="Calibri" pitchFamily="34" charset="-120"/>
+              </a:rPr>
+              <a:t>Products &amp; Inventory</a:t>
+            </a:r>
+            <a:endParaRPr lang="en-US" sz="1200" dirty="0"/>
+          </a:p>
+        </p:txBody>
+      </p:sp>
+      <p:sp>
+        <p:nvSpPr>
+          <p:cNvPr id="16" name="Text 13"/>
+          <p:cNvSpPr/>
+          <p:nvPr/>
+        </p:nvSpPr>
+        <p:spPr>
+          <a:xfrm>
+            <a:off x="9272016" y="2130552"/>
+            <a:ext cx="2194560" cy="365760"/>
           </a:xfrm>
           <a:prstGeom prst="rect">
             <a:avLst/>
@@ -8802,46 +8806,7 @@
               <a:buNone/>
             </a:pPr>
             <a:r>
-              <a:rPr lang="en-US" sz="1450" b="1" dirty="0">
-                <a:solidFill>
-                  <a:srgbClr val="F5F0E6"/>
-                </a:solidFill>
-                <a:latin typeface="Calibri" pitchFamily="34" charset="0"/>
-                <a:ea typeface="Calibri" pitchFamily="34" charset="-122"/>
-                <a:cs typeface="Calibri" pitchFamily="34" charset="-120"/>
-              </a:rPr>
-              <a:t>Customers</a:t>
-            </a:r>
-            <a:endParaRPr lang="en-US" sz="1450" dirty="0"/>
-          </a:p>
-        </p:txBody>
-      </p:sp>
-      <p:sp>
-        <p:nvSpPr>
-          <p:cNvPr id="17" name="Text 15"/>
-          <p:cNvSpPr/>
-          <p:nvPr/>
-        </p:nvSpPr>
-        <p:spPr>
-          <a:xfrm>
-            <a:off x="6355080" y="2560320"/>
-            <a:ext cx="2249424" cy="896112"/>
-          </a:xfrm>
-          <a:prstGeom prst="rect">
-            <a:avLst/>
-          </a:prstGeom>
-          <a:noFill/>
-          <a:ln/>
-        </p:spPr>
-        <p:txBody>
-          <a:bodyPr wrap="square" rtlCol="0" anchor="t"/>
-          <a:lstStyle/>
-          <a:p>
-            <a:pPr indent="0" marL="0">
-              <a:buNone/>
-            </a:pPr>
-            <a:r>
-              <a:rPr lang="en-US" sz="1150" dirty="0">
+              <a:rPr lang="en-US" sz="900" dirty="0">
                 <a:solidFill>
                   <a:srgbClr val="C7D2E4"/>
                 </a:solidFill>
@@ -8849,26 +8814,26 @@
                 <a:ea typeface="Calibri" pitchFamily="34" charset="-122"/>
                 <a:cs typeface="Calibri" pitchFamily="34" charset="-120"/>
               </a:rPr>
-              <a:t>Profiles, history, outstanding balances and returns.</a:t>
-            </a:r>
-            <a:endParaRPr lang="en-US" sz="1150" dirty="0"/>
-          </a:p>
-        </p:txBody>
-      </p:sp>
-      <p:sp>
-        <p:nvSpPr>
-          <p:cNvPr id="18" name="Shape 16"/>
-          <p:cNvSpPr/>
-          <p:nvPr/>
-        </p:nvSpPr>
-        <p:spPr>
-          <a:xfrm>
-            <a:off x="8979408" y="1645920"/>
-            <a:ext cx="2651760" cy="1920240"/>
+              <a:t>SKUs, barcodes, categories, warehouses and stock movements.</a:t>
+            </a:r>
+            <a:endParaRPr lang="en-US" sz="900" dirty="0"/>
+          </a:p>
+        </p:txBody>
+      </p:sp>
+      <p:sp>
+        <p:nvSpPr>
+          <p:cNvPr id="17" name="Shape 14"/>
+          <p:cNvSpPr/>
+          <p:nvPr/>
+        </p:nvSpPr>
+        <p:spPr>
+          <a:xfrm>
+            <a:off x="6400800" y="2660904"/>
+            <a:ext cx="2523744" cy="873252"/>
           </a:xfrm>
           <a:prstGeom prst="roundRect">
             <a:avLst>
-              <a:gd name="adj" fmla="val 4286"/>
+              <a:gd name="adj" fmla="val 9424"/>
             </a:avLst>
           </a:prstGeom>
           <a:solidFill>
@@ -8884,34 +8849,73 @@
       </p:sp>
       <p:sp>
         <p:nvSpPr>
-          <p:cNvPr id="19" name="Shape 17"/>
-          <p:cNvSpPr/>
-          <p:nvPr/>
-        </p:nvSpPr>
-        <p:spPr>
-          <a:xfrm>
-            <a:off x="9180576" y="1865376"/>
-            <a:ext cx="457200" cy="64008"/>
-          </a:xfrm>
-          <a:prstGeom prst="rect">
-            <a:avLst/>
-          </a:prstGeom>
-          <a:solidFill>
-            <a:srgbClr val="0E9488"/>
-          </a:solidFill>
-          <a:ln/>
-        </p:spPr>
-      </p:sp>
-      <p:sp>
-        <p:nvSpPr>
-          <p:cNvPr id="20" name="Text 18"/>
-          <p:cNvSpPr/>
-          <p:nvPr/>
-        </p:nvSpPr>
-        <p:spPr>
-          <a:xfrm>
-            <a:off x="9180576" y="2011680"/>
-            <a:ext cx="2249424" cy="566928"/>
+          <p:cNvPr id="18" name="Shape 15"/>
+          <p:cNvSpPr/>
+          <p:nvPr/>
+        </p:nvSpPr>
+        <p:spPr>
+          <a:xfrm>
+            <a:off x="6565392" y="2807208"/>
+            <a:ext cx="384048" cy="50292"/>
+          </a:xfrm>
+          <a:prstGeom prst="rect">
+            <a:avLst/>
+          </a:prstGeom>
+          <a:solidFill>
+            <a:srgbClr val="F5A314"/>
+          </a:solidFill>
+          <a:ln/>
+        </p:spPr>
+      </p:sp>
+      <p:sp>
+        <p:nvSpPr>
+          <p:cNvPr id="19" name="Text 16"/>
+          <p:cNvSpPr/>
+          <p:nvPr/>
+        </p:nvSpPr>
+        <p:spPr>
+          <a:xfrm>
+            <a:off x="6565392" y="2898648"/>
+            <a:ext cx="2194560" cy="237744"/>
+          </a:xfrm>
+          <a:prstGeom prst="rect">
+            <a:avLst/>
+          </a:prstGeom>
+          <a:noFill/>
+          <a:ln/>
+        </p:spPr>
+        <p:txBody>
+          <a:bodyPr wrap="square" rtlCol="0" anchor="ctr"/>
+          <a:lstStyle/>
+          <a:p>
+            <a:pPr indent="0" marL="0">
+              <a:buNone/>
+            </a:pPr>
+            <a:r>
+              <a:rPr lang="en-US" sz="1200" b="1" dirty="0">
+                <a:solidFill>
+                  <a:srgbClr val="F5F0E6"/>
+                </a:solidFill>
+                <a:latin typeface="Calibri" pitchFamily="34" charset="0"/>
+                <a:ea typeface="Calibri" pitchFamily="34" charset="-122"/>
+                <a:cs typeface="Calibri" pitchFamily="34" charset="-120"/>
+              </a:rPr>
+              <a:t>Customers</a:t>
+            </a:r>
+            <a:endParaRPr lang="en-US" sz="1200" dirty="0"/>
+          </a:p>
+        </p:txBody>
+      </p:sp>
+      <p:sp>
+        <p:nvSpPr>
+          <p:cNvPr id="20" name="Text 17"/>
+          <p:cNvSpPr/>
+          <p:nvPr/>
+        </p:nvSpPr>
+        <p:spPr>
+          <a:xfrm>
+            <a:off x="6565392" y="3145536"/>
+            <a:ext cx="2194560" cy="365760"/>
           </a:xfrm>
           <a:prstGeom prst="rect">
             <a:avLst/>
@@ -8927,46 +8931,7 @@
               <a:buNone/>
             </a:pPr>
             <a:r>
-              <a:rPr lang="en-US" sz="1450" b="1" dirty="0">
-                <a:solidFill>
-                  <a:srgbClr val="F5F0E6"/>
-                </a:solidFill>
-                <a:latin typeface="Calibri" pitchFamily="34" charset="0"/>
-                <a:ea typeface="Calibri" pitchFamily="34" charset="-122"/>
-                <a:cs typeface="Calibri" pitchFamily="34" charset="-120"/>
-              </a:rPr>
-              <a:t>Sales &amp; Invoicing</a:t>
-            </a:r>
-            <a:endParaRPr lang="en-US" sz="1450" dirty="0"/>
-          </a:p>
-        </p:txBody>
-      </p:sp>
-      <p:sp>
-        <p:nvSpPr>
-          <p:cNvPr id="21" name="Text 19"/>
-          <p:cNvSpPr/>
-          <p:nvPr/>
-        </p:nvSpPr>
-        <p:spPr>
-          <a:xfrm>
-            <a:off x="9180576" y="2560320"/>
-            <a:ext cx="2249424" cy="896112"/>
-          </a:xfrm>
-          <a:prstGeom prst="rect">
-            <a:avLst/>
-          </a:prstGeom>
-          <a:noFill/>
-          <a:ln/>
-        </p:spPr>
-        <p:txBody>
-          <a:bodyPr wrap="square" rtlCol="0" anchor="t"/>
-          <a:lstStyle/>
-          <a:p>
-            <a:pPr indent="0" marL="0">
-              <a:buNone/>
-            </a:pPr>
-            <a:r>
-              <a:rPr lang="en-US" sz="1150" dirty="0">
+              <a:rPr lang="en-US" sz="900" dirty="0">
                 <a:solidFill>
                   <a:srgbClr val="C7D2E4"/>
                 </a:solidFill>
@@ -8974,26 +8939,26 @@
                 <a:ea typeface="Calibri" pitchFamily="34" charset="-122"/>
                 <a:cs typeface="Calibri" pitchFamily="34" charset="-120"/>
               </a:rPr>
-              <a:t>Invoices, line items, partial payments and statuses.</a:t>
-            </a:r>
-            <a:endParaRPr lang="en-US" sz="1150" dirty="0"/>
-          </a:p>
-        </p:txBody>
-      </p:sp>
-      <p:sp>
-        <p:nvSpPr>
-          <p:cNvPr id="22" name="Shape 20"/>
-          <p:cNvSpPr/>
-          <p:nvPr/>
-        </p:nvSpPr>
-        <p:spPr>
-          <a:xfrm>
-            <a:off x="502920" y="3749040"/>
-            <a:ext cx="2651760" cy="1920240"/>
+              <a:t>Profiles, history, outstanding balances and returns.</a:t>
+            </a:r>
+            <a:endParaRPr lang="en-US" sz="900" dirty="0"/>
+          </a:p>
+        </p:txBody>
+      </p:sp>
+      <p:sp>
+        <p:nvSpPr>
+          <p:cNvPr id="21" name="Shape 18"/>
+          <p:cNvSpPr/>
+          <p:nvPr/>
+        </p:nvSpPr>
+        <p:spPr>
+          <a:xfrm>
+            <a:off x="9107424" y="2660904"/>
+            <a:ext cx="2523744" cy="873252"/>
           </a:xfrm>
           <a:prstGeom prst="roundRect">
             <a:avLst>
-              <a:gd name="adj" fmla="val 4286"/>
+              <a:gd name="adj" fmla="val 9424"/>
             </a:avLst>
           </a:prstGeom>
           <a:solidFill>
@@ -9009,34 +8974,73 @@
       </p:sp>
       <p:sp>
         <p:nvSpPr>
-          <p:cNvPr id="23" name="Shape 21"/>
-          <p:cNvSpPr/>
-          <p:nvPr/>
-        </p:nvSpPr>
-        <p:spPr>
-          <a:xfrm>
-            <a:off x="704088" y="3968496"/>
-            <a:ext cx="457200" cy="64008"/>
-          </a:xfrm>
-          <a:prstGeom prst="rect">
-            <a:avLst/>
-          </a:prstGeom>
-          <a:solidFill>
-            <a:srgbClr val="F5A314"/>
-          </a:solidFill>
-          <a:ln/>
-        </p:spPr>
-      </p:sp>
-      <p:sp>
-        <p:nvSpPr>
-          <p:cNvPr id="24" name="Text 22"/>
-          <p:cNvSpPr/>
-          <p:nvPr/>
-        </p:nvSpPr>
-        <p:spPr>
-          <a:xfrm>
-            <a:off x="704088" y="4114800"/>
-            <a:ext cx="2249424" cy="566928"/>
+          <p:cNvPr id="22" name="Shape 19"/>
+          <p:cNvSpPr/>
+          <p:nvPr/>
+        </p:nvSpPr>
+        <p:spPr>
+          <a:xfrm>
+            <a:off x="9272016" y="2807208"/>
+            <a:ext cx="384048" cy="50292"/>
+          </a:xfrm>
+          <a:prstGeom prst="rect">
+            <a:avLst/>
+          </a:prstGeom>
+          <a:solidFill>
+            <a:srgbClr val="0E9488"/>
+          </a:solidFill>
+          <a:ln/>
+        </p:spPr>
+      </p:sp>
+      <p:sp>
+        <p:nvSpPr>
+          <p:cNvPr id="23" name="Text 20"/>
+          <p:cNvSpPr/>
+          <p:nvPr/>
+        </p:nvSpPr>
+        <p:spPr>
+          <a:xfrm>
+            <a:off x="9272016" y="2898648"/>
+            <a:ext cx="2194560" cy="237744"/>
+          </a:xfrm>
+          <a:prstGeom prst="rect">
+            <a:avLst/>
+          </a:prstGeom>
+          <a:noFill/>
+          <a:ln/>
+        </p:spPr>
+        <p:txBody>
+          <a:bodyPr wrap="square" rtlCol="0" anchor="ctr"/>
+          <a:lstStyle/>
+          <a:p>
+            <a:pPr indent="0" marL="0">
+              <a:buNone/>
+            </a:pPr>
+            <a:r>
+              <a:rPr lang="en-US" sz="1200" b="1" dirty="0">
+                <a:solidFill>
+                  <a:srgbClr val="F5F0E6"/>
+                </a:solidFill>
+                <a:latin typeface="Calibri" pitchFamily="34" charset="0"/>
+                <a:ea typeface="Calibri" pitchFamily="34" charset="-122"/>
+                <a:cs typeface="Calibri" pitchFamily="34" charset="-120"/>
+              </a:rPr>
+              <a:t>Sales &amp; Invoicing</a:t>
+            </a:r>
+            <a:endParaRPr lang="en-US" sz="1200" dirty="0"/>
+          </a:p>
+        </p:txBody>
+      </p:sp>
+      <p:sp>
+        <p:nvSpPr>
+          <p:cNvPr id="24" name="Text 21"/>
+          <p:cNvSpPr/>
+          <p:nvPr/>
+        </p:nvSpPr>
+        <p:spPr>
+          <a:xfrm>
+            <a:off x="9272016" y="3145536"/>
+            <a:ext cx="2194560" cy="365760"/>
           </a:xfrm>
           <a:prstGeom prst="rect">
             <a:avLst/>
@@ -9052,46 +9056,7 @@
               <a:buNone/>
             </a:pPr>
             <a:r>
-              <a:rPr lang="en-US" sz="1450" b="1" dirty="0">
-                <a:solidFill>
-                  <a:srgbClr val="F5F0E6"/>
-                </a:solidFill>
-                <a:latin typeface="Calibri" pitchFamily="34" charset="0"/>
-                <a:ea typeface="Calibri" pitchFamily="34" charset="-122"/>
-                <a:cs typeface="Calibri" pitchFamily="34" charset="-120"/>
-              </a:rPr>
-              <a:t>Purchasing</a:t>
-            </a:r>
-            <a:endParaRPr lang="en-US" sz="1450" dirty="0"/>
-          </a:p>
-        </p:txBody>
-      </p:sp>
-      <p:sp>
-        <p:nvSpPr>
-          <p:cNvPr id="25" name="Text 23"/>
-          <p:cNvSpPr/>
-          <p:nvPr/>
-        </p:nvSpPr>
-        <p:spPr>
-          <a:xfrm>
-            <a:off x="704088" y="4663440"/>
-            <a:ext cx="2249424" cy="896112"/>
-          </a:xfrm>
-          <a:prstGeom prst="rect">
-            <a:avLst/>
-          </a:prstGeom>
-          <a:noFill/>
-          <a:ln/>
-        </p:spPr>
-        <p:txBody>
-          <a:bodyPr wrap="square" rtlCol="0" anchor="t"/>
-          <a:lstStyle/>
-          <a:p>
-            <a:pPr indent="0" marL="0">
-              <a:buNone/>
-            </a:pPr>
-            <a:r>
-              <a:rPr lang="en-US" sz="1150" dirty="0">
+              <a:rPr lang="en-US" sz="900" dirty="0">
                 <a:solidFill>
                   <a:srgbClr val="C7D2E4"/>
                 </a:solidFill>
@@ -9099,26 +9064,26 @@
                 <a:ea typeface="Calibri" pitchFamily="34" charset="-122"/>
                 <a:cs typeface="Calibri" pitchFamily="34" charset="-120"/>
               </a:rPr>
-              <a:t>Supplier → purchase order → receiving → stock → balance.</a:t>
-            </a:r>
-            <a:endParaRPr lang="en-US" sz="1150" dirty="0"/>
-          </a:p>
-        </p:txBody>
-      </p:sp>
-      <p:sp>
-        <p:nvSpPr>
-          <p:cNvPr id="26" name="Shape 24"/>
-          <p:cNvSpPr/>
-          <p:nvPr/>
-        </p:nvSpPr>
-        <p:spPr>
-          <a:xfrm>
-            <a:off x="3328416" y="3749040"/>
-            <a:ext cx="2651760" cy="1920240"/>
+              <a:t>Invoices, line items, partial payments and statuses.</a:t>
+            </a:r>
+            <a:endParaRPr lang="en-US" sz="900" dirty="0"/>
+          </a:p>
+        </p:txBody>
+      </p:sp>
+      <p:sp>
+        <p:nvSpPr>
+          <p:cNvPr id="25" name="Shape 22"/>
+          <p:cNvSpPr/>
+          <p:nvPr/>
+        </p:nvSpPr>
+        <p:spPr>
+          <a:xfrm>
+            <a:off x="6400800" y="3675888"/>
+            <a:ext cx="2523744" cy="873252"/>
           </a:xfrm>
           <a:prstGeom prst="roundRect">
             <a:avLst>
-              <a:gd name="adj" fmla="val 4286"/>
+              <a:gd name="adj" fmla="val 9424"/>
             </a:avLst>
           </a:prstGeom>
           <a:solidFill>
@@ -9134,34 +9099,73 @@
       </p:sp>
       <p:sp>
         <p:nvSpPr>
-          <p:cNvPr id="27" name="Shape 25"/>
-          <p:cNvSpPr/>
-          <p:nvPr/>
-        </p:nvSpPr>
-        <p:spPr>
-          <a:xfrm>
-            <a:off x="3529584" y="3968496"/>
-            <a:ext cx="457200" cy="64008"/>
-          </a:xfrm>
-          <a:prstGeom prst="rect">
-            <a:avLst/>
-          </a:prstGeom>
-          <a:solidFill>
-            <a:srgbClr val="0E9488"/>
-          </a:solidFill>
-          <a:ln/>
-        </p:spPr>
-      </p:sp>
-      <p:sp>
-        <p:nvSpPr>
-          <p:cNvPr id="28" name="Text 26"/>
-          <p:cNvSpPr/>
-          <p:nvPr/>
-        </p:nvSpPr>
-        <p:spPr>
-          <a:xfrm>
-            <a:off x="3529584" y="4114800"/>
-            <a:ext cx="2249424" cy="566928"/>
+          <p:cNvPr id="26" name="Shape 23"/>
+          <p:cNvSpPr/>
+          <p:nvPr/>
+        </p:nvSpPr>
+        <p:spPr>
+          <a:xfrm>
+            <a:off x="6565392" y="3822192"/>
+            <a:ext cx="384048" cy="50292"/>
+          </a:xfrm>
+          <a:prstGeom prst="rect">
+            <a:avLst/>
+          </a:prstGeom>
+          <a:solidFill>
+            <a:srgbClr val="F5A314"/>
+          </a:solidFill>
+          <a:ln/>
+        </p:spPr>
+      </p:sp>
+      <p:sp>
+        <p:nvSpPr>
+          <p:cNvPr id="27" name="Text 24"/>
+          <p:cNvSpPr/>
+          <p:nvPr/>
+        </p:nvSpPr>
+        <p:spPr>
+          <a:xfrm>
+            <a:off x="6565392" y="3913632"/>
+            <a:ext cx="2194560" cy="237744"/>
+          </a:xfrm>
+          <a:prstGeom prst="rect">
+            <a:avLst/>
+          </a:prstGeom>
+          <a:noFill/>
+          <a:ln/>
+        </p:spPr>
+        <p:txBody>
+          <a:bodyPr wrap="square" rtlCol="0" anchor="ctr"/>
+          <a:lstStyle/>
+          <a:p>
+            <a:pPr indent="0" marL="0">
+              <a:buNone/>
+            </a:pPr>
+            <a:r>
+              <a:rPr lang="en-US" sz="1200" b="1" dirty="0">
+                <a:solidFill>
+                  <a:srgbClr val="F5F0E6"/>
+                </a:solidFill>
+                <a:latin typeface="Calibri" pitchFamily="34" charset="0"/>
+                <a:ea typeface="Calibri" pitchFamily="34" charset="-122"/>
+                <a:cs typeface="Calibri" pitchFamily="34" charset="-120"/>
+              </a:rPr>
+              <a:t>Purchasing</a:t>
+            </a:r>
+            <a:endParaRPr lang="en-US" sz="1200" dirty="0"/>
+          </a:p>
+        </p:txBody>
+      </p:sp>
+      <p:sp>
+        <p:nvSpPr>
+          <p:cNvPr id="28" name="Text 25"/>
+          <p:cNvSpPr/>
+          <p:nvPr/>
+        </p:nvSpPr>
+        <p:spPr>
+          <a:xfrm>
+            <a:off x="6565392" y="4160520"/>
+            <a:ext cx="2194560" cy="365760"/>
           </a:xfrm>
           <a:prstGeom prst="rect">
             <a:avLst/>
@@ -9177,46 +9181,7 @@
               <a:buNone/>
             </a:pPr>
             <a:r>
-              <a:rPr lang="en-US" sz="1450" b="1" dirty="0">
-                <a:solidFill>
-                  <a:srgbClr val="F5F0E6"/>
-                </a:solidFill>
-                <a:latin typeface="Calibri" pitchFamily="34" charset="0"/>
-                <a:ea typeface="Calibri" pitchFamily="34" charset="-122"/>
-                <a:cs typeface="Calibri" pitchFamily="34" charset="-120"/>
-              </a:rPr>
-              <a:t>Payments</a:t>
-            </a:r>
-            <a:endParaRPr lang="en-US" sz="1450" dirty="0"/>
-          </a:p>
-        </p:txBody>
-      </p:sp>
-      <p:sp>
-        <p:nvSpPr>
-          <p:cNvPr id="29" name="Text 27"/>
-          <p:cNvSpPr/>
-          <p:nvPr/>
-        </p:nvSpPr>
-        <p:spPr>
-          <a:xfrm>
-            <a:off x="3529584" y="4663440"/>
-            <a:ext cx="2249424" cy="896112"/>
-          </a:xfrm>
-          <a:prstGeom prst="rect">
-            <a:avLst/>
-          </a:prstGeom>
-          <a:noFill/>
-          <a:ln/>
-        </p:spPr>
-        <p:txBody>
-          <a:bodyPr wrap="square" rtlCol="0" anchor="t"/>
-          <a:lstStyle/>
-          <a:p>
-            <a:pPr indent="0" marL="0">
-              <a:buNone/>
-            </a:pPr>
-            <a:r>
-              <a:rPr lang="en-US" sz="1150" dirty="0">
+              <a:rPr lang="en-US" sz="900" dirty="0">
                 <a:solidFill>
                   <a:srgbClr val="C7D2E4"/>
                 </a:solidFill>
@@ -9224,26 +9189,26 @@
                 <a:ea typeface="Calibri" pitchFamily="34" charset="-122"/>
                 <a:cs typeface="Calibri" pitchFamily="34" charset="-120"/>
               </a:rPr>
-              <a:t>Card (Paystack) and M-PESA rails, refunds and tracking.</a:t>
-            </a:r>
-            <a:endParaRPr lang="en-US" sz="1150" dirty="0"/>
-          </a:p>
-        </p:txBody>
-      </p:sp>
-      <p:sp>
-        <p:nvSpPr>
-          <p:cNvPr id="30" name="Shape 28"/>
-          <p:cNvSpPr/>
-          <p:nvPr/>
-        </p:nvSpPr>
-        <p:spPr>
-          <a:xfrm>
-            <a:off x="6153912" y="3749040"/>
-            <a:ext cx="2651760" cy="1920240"/>
+              <a:t>Supplier → purchase order → receiving → stock → balance.</a:t>
+            </a:r>
+            <a:endParaRPr lang="en-US" sz="900" dirty="0"/>
+          </a:p>
+        </p:txBody>
+      </p:sp>
+      <p:sp>
+        <p:nvSpPr>
+          <p:cNvPr id="29" name="Shape 26"/>
+          <p:cNvSpPr/>
+          <p:nvPr/>
+        </p:nvSpPr>
+        <p:spPr>
+          <a:xfrm>
+            <a:off x="9107424" y="3675888"/>
+            <a:ext cx="2523744" cy="873252"/>
           </a:xfrm>
           <a:prstGeom prst="roundRect">
             <a:avLst>
-              <a:gd name="adj" fmla="val 4286"/>
+              <a:gd name="adj" fmla="val 9424"/>
             </a:avLst>
           </a:prstGeom>
           <a:solidFill>
@@ -9259,34 +9224,73 @@
       </p:sp>
       <p:sp>
         <p:nvSpPr>
-          <p:cNvPr id="31" name="Shape 29"/>
-          <p:cNvSpPr/>
-          <p:nvPr/>
-        </p:nvSpPr>
-        <p:spPr>
-          <a:xfrm>
-            <a:off x="6355080" y="3968496"/>
-            <a:ext cx="457200" cy="64008"/>
-          </a:xfrm>
-          <a:prstGeom prst="rect">
-            <a:avLst/>
-          </a:prstGeom>
-          <a:solidFill>
-            <a:srgbClr val="F5A314"/>
-          </a:solidFill>
-          <a:ln/>
-        </p:spPr>
-      </p:sp>
-      <p:sp>
-        <p:nvSpPr>
-          <p:cNvPr id="32" name="Text 30"/>
-          <p:cNvSpPr/>
-          <p:nvPr/>
-        </p:nvSpPr>
-        <p:spPr>
-          <a:xfrm>
-            <a:off x="6355080" y="4114800"/>
-            <a:ext cx="2249424" cy="566928"/>
+          <p:cNvPr id="30" name="Shape 27"/>
+          <p:cNvSpPr/>
+          <p:nvPr/>
+        </p:nvSpPr>
+        <p:spPr>
+          <a:xfrm>
+            <a:off x="9272016" y="3822192"/>
+            <a:ext cx="384048" cy="50292"/>
+          </a:xfrm>
+          <a:prstGeom prst="rect">
+            <a:avLst/>
+          </a:prstGeom>
+          <a:solidFill>
+            <a:srgbClr val="0E9488"/>
+          </a:solidFill>
+          <a:ln/>
+        </p:spPr>
+      </p:sp>
+      <p:sp>
+        <p:nvSpPr>
+          <p:cNvPr id="31" name="Text 28"/>
+          <p:cNvSpPr/>
+          <p:nvPr/>
+        </p:nvSpPr>
+        <p:spPr>
+          <a:xfrm>
+            <a:off x="9272016" y="3913632"/>
+            <a:ext cx="2194560" cy="237744"/>
+          </a:xfrm>
+          <a:prstGeom prst="rect">
+            <a:avLst/>
+          </a:prstGeom>
+          <a:noFill/>
+          <a:ln/>
+        </p:spPr>
+        <p:txBody>
+          <a:bodyPr wrap="square" rtlCol="0" anchor="ctr"/>
+          <a:lstStyle/>
+          <a:p>
+            <a:pPr indent="0" marL="0">
+              <a:buNone/>
+            </a:pPr>
+            <a:r>
+              <a:rPr lang="en-US" sz="1200" b="1" dirty="0">
+                <a:solidFill>
+                  <a:srgbClr val="F5F0E6"/>
+                </a:solidFill>
+                <a:latin typeface="Calibri" pitchFamily="34" charset="0"/>
+                <a:ea typeface="Calibri" pitchFamily="34" charset="-122"/>
+                <a:cs typeface="Calibri" pitchFamily="34" charset="-120"/>
+              </a:rPr>
+              <a:t>Payments</a:t>
+            </a:r>
+            <a:endParaRPr lang="en-US" sz="1200" dirty="0"/>
+          </a:p>
+        </p:txBody>
+      </p:sp>
+      <p:sp>
+        <p:nvSpPr>
+          <p:cNvPr id="32" name="Text 29"/>
+          <p:cNvSpPr/>
+          <p:nvPr/>
+        </p:nvSpPr>
+        <p:spPr>
+          <a:xfrm>
+            <a:off x="9272016" y="4160520"/>
+            <a:ext cx="2194560" cy="365760"/>
           </a:xfrm>
           <a:prstGeom prst="rect">
             <a:avLst/>
@@ -9302,46 +9306,7 @@
               <a:buNone/>
             </a:pPr>
             <a:r>
-              <a:rPr lang="en-US" sz="1450" b="1" dirty="0">
-                <a:solidFill>
-                  <a:srgbClr val="F5F0E6"/>
-                </a:solidFill>
-                <a:latin typeface="Calibri" pitchFamily="34" charset="0"/>
-                <a:ea typeface="Calibri" pitchFamily="34" charset="-122"/>
-                <a:cs typeface="Calibri" pitchFamily="34" charset="-120"/>
-              </a:rPr>
-              <a:t>Reporting</a:t>
-            </a:r>
-            <a:endParaRPr lang="en-US" sz="1450" dirty="0"/>
-          </a:p>
-        </p:txBody>
-      </p:sp>
-      <p:sp>
-        <p:nvSpPr>
-          <p:cNvPr id="33" name="Text 31"/>
-          <p:cNvSpPr/>
-          <p:nvPr/>
-        </p:nvSpPr>
-        <p:spPr>
-          <a:xfrm>
-            <a:off x="6355080" y="4663440"/>
-            <a:ext cx="2249424" cy="896112"/>
-          </a:xfrm>
-          <a:prstGeom prst="rect">
-            <a:avLst/>
-          </a:prstGeom>
-          <a:noFill/>
-          <a:ln/>
-        </p:spPr>
-        <p:txBody>
-          <a:bodyPr wrap="square" rtlCol="0" anchor="t"/>
-          <a:lstStyle/>
-          <a:p>
-            <a:pPr indent="0" marL="0">
-              <a:buNone/>
-            </a:pPr>
-            <a:r>
-              <a:rPr lang="en-US" sz="1150" dirty="0">
+              <a:rPr lang="en-US" sz="900" dirty="0">
                 <a:solidFill>
                   <a:srgbClr val="C7D2E4"/>
                 </a:solidFill>
@@ -9349,26 +9314,26 @@
                 <a:ea typeface="Calibri" pitchFamily="34" charset="-122"/>
                 <a:cs typeface="Calibri" pitchFamily="34" charset="-120"/>
               </a:rPr>
-              <a:t>Sales, stock, customer and financial reports.</a:t>
-            </a:r>
-            <a:endParaRPr lang="en-US" sz="1150" dirty="0"/>
-          </a:p>
-        </p:txBody>
-      </p:sp>
-      <p:sp>
-        <p:nvSpPr>
-          <p:cNvPr id="34" name="Shape 32"/>
-          <p:cNvSpPr/>
-          <p:nvPr/>
-        </p:nvSpPr>
-        <p:spPr>
-          <a:xfrm>
-            <a:off x="8979408" y="3749040"/>
-            <a:ext cx="2651760" cy="1920240"/>
+              <a:t>Card (Paystack) and M-PESA rails, refunds and tracking.</a:t>
+            </a:r>
+            <a:endParaRPr lang="en-US" sz="900" dirty="0"/>
+          </a:p>
+        </p:txBody>
+      </p:sp>
+      <p:sp>
+        <p:nvSpPr>
+          <p:cNvPr id="33" name="Shape 30"/>
+          <p:cNvSpPr/>
+          <p:nvPr/>
+        </p:nvSpPr>
+        <p:spPr>
+          <a:xfrm>
+            <a:off x="6400800" y="4690872"/>
+            <a:ext cx="2523744" cy="873252"/>
           </a:xfrm>
           <a:prstGeom prst="roundRect">
             <a:avLst>
-              <a:gd name="adj" fmla="val 4286"/>
+              <a:gd name="adj" fmla="val 9424"/>
             </a:avLst>
           </a:prstGeom>
           <a:solidFill>
@@ -9384,34 +9349,73 @@
       </p:sp>
       <p:sp>
         <p:nvSpPr>
-          <p:cNvPr id="35" name="Shape 33"/>
-          <p:cNvSpPr/>
-          <p:nvPr/>
-        </p:nvSpPr>
-        <p:spPr>
-          <a:xfrm>
-            <a:off x="9180576" y="3968496"/>
-            <a:ext cx="457200" cy="64008"/>
-          </a:xfrm>
-          <a:prstGeom prst="rect">
-            <a:avLst/>
-          </a:prstGeom>
-          <a:solidFill>
-            <a:srgbClr val="0E9488"/>
-          </a:solidFill>
-          <a:ln/>
-        </p:spPr>
-      </p:sp>
-      <p:sp>
-        <p:nvSpPr>
-          <p:cNvPr id="36" name="Text 34"/>
-          <p:cNvSpPr/>
-          <p:nvPr/>
-        </p:nvSpPr>
-        <p:spPr>
-          <a:xfrm>
-            <a:off x="9180576" y="4114800"/>
-            <a:ext cx="2249424" cy="566928"/>
+          <p:cNvPr id="34" name="Shape 31"/>
+          <p:cNvSpPr/>
+          <p:nvPr/>
+        </p:nvSpPr>
+        <p:spPr>
+          <a:xfrm>
+            <a:off x="6565392" y="4837176"/>
+            <a:ext cx="384048" cy="50292"/>
+          </a:xfrm>
+          <a:prstGeom prst="rect">
+            <a:avLst/>
+          </a:prstGeom>
+          <a:solidFill>
+            <a:srgbClr val="F5A314"/>
+          </a:solidFill>
+          <a:ln/>
+        </p:spPr>
+      </p:sp>
+      <p:sp>
+        <p:nvSpPr>
+          <p:cNvPr id="35" name="Text 32"/>
+          <p:cNvSpPr/>
+          <p:nvPr/>
+        </p:nvSpPr>
+        <p:spPr>
+          <a:xfrm>
+            <a:off x="6565392" y="4928616"/>
+            <a:ext cx="2194560" cy="237744"/>
+          </a:xfrm>
+          <a:prstGeom prst="rect">
+            <a:avLst/>
+          </a:prstGeom>
+          <a:noFill/>
+          <a:ln/>
+        </p:spPr>
+        <p:txBody>
+          <a:bodyPr wrap="square" rtlCol="0" anchor="ctr"/>
+          <a:lstStyle/>
+          <a:p>
+            <a:pPr indent="0" marL="0">
+              <a:buNone/>
+            </a:pPr>
+            <a:r>
+              <a:rPr lang="en-US" sz="1200" b="1" dirty="0">
+                <a:solidFill>
+                  <a:srgbClr val="F5F0E6"/>
+                </a:solidFill>
+                <a:latin typeface="Calibri" pitchFamily="34" charset="0"/>
+                <a:ea typeface="Calibri" pitchFamily="34" charset="-122"/>
+                <a:cs typeface="Calibri" pitchFamily="34" charset="-120"/>
+              </a:rPr>
+              <a:t>Reporting</a:t>
+            </a:r>
+            <a:endParaRPr lang="en-US" sz="1200" dirty="0"/>
+          </a:p>
+        </p:txBody>
+      </p:sp>
+      <p:sp>
+        <p:nvSpPr>
+          <p:cNvPr id="36" name="Text 33"/>
+          <p:cNvSpPr/>
+          <p:nvPr/>
+        </p:nvSpPr>
+        <p:spPr>
+          <a:xfrm>
+            <a:off x="6565392" y="5175504"/>
+            <a:ext cx="2194560" cy="365760"/>
           </a:xfrm>
           <a:prstGeom prst="rect">
             <a:avLst/>
@@ -9427,46 +9431,7 @@
               <a:buNone/>
             </a:pPr>
             <a:r>
-              <a:rPr lang="en-US" sz="1450" b="1" dirty="0">
-                <a:solidFill>
-                  <a:srgbClr val="F5F0E6"/>
-                </a:solidFill>
-                <a:latin typeface="Calibri" pitchFamily="34" charset="0"/>
-                <a:ea typeface="Calibri" pitchFamily="34" charset="-122"/>
-                <a:cs typeface="Calibri" pitchFamily="34" charset="-120"/>
-              </a:rPr>
-              <a:t>AI Insights</a:t>
-            </a:r>
-            <a:endParaRPr lang="en-US" sz="1450" dirty="0"/>
-          </a:p>
-        </p:txBody>
-      </p:sp>
-      <p:sp>
-        <p:nvSpPr>
-          <p:cNvPr id="37" name="Text 35"/>
-          <p:cNvSpPr/>
-          <p:nvPr/>
-        </p:nvSpPr>
-        <p:spPr>
-          <a:xfrm>
-            <a:off x="9180576" y="4663440"/>
-            <a:ext cx="2249424" cy="896112"/>
-          </a:xfrm>
-          <a:prstGeom prst="rect">
-            <a:avLst/>
-          </a:prstGeom>
-          <a:noFill/>
-          <a:ln/>
-        </p:spPr>
-        <p:txBody>
-          <a:bodyPr wrap="square" rtlCol="0" anchor="t"/>
-          <a:lstStyle/>
-          <a:p>
-            <a:pPr indent="0" marL="0">
-              <a:buNone/>
-            </a:pPr>
-            <a:r>
-              <a:rPr lang="en-US" sz="1150" dirty="0">
+              <a:rPr lang="en-US" sz="900" dirty="0">
                 <a:solidFill>
                   <a:srgbClr val="C7D2E4"/>
                 </a:solidFill>
@@ -9474,30 +9439,30 @@
                 <a:ea typeface="Calibri" pitchFamily="34" charset="-122"/>
                 <a:cs typeface="Calibri" pitchFamily="34" charset="-120"/>
               </a:rPr>
-              <a:t>Business intelligence grounded in your own numbers.</a:t>
-            </a:r>
-            <a:endParaRPr lang="en-US" sz="1150" dirty="0"/>
-          </a:p>
-        </p:txBody>
-      </p:sp>
-      <p:sp>
-        <p:nvSpPr>
-          <p:cNvPr id="38" name="Shape 36"/>
-          <p:cNvSpPr/>
-          <p:nvPr/>
-        </p:nvSpPr>
-        <p:spPr>
-          <a:xfrm>
-            <a:off x="502920" y="5852160"/>
-            <a:ext cx="11128248" cy="457200"/>
+              <a:t>Sales, stock, customer and financial reports.</a:t>
+            </a:r>
+            <a:endParaRPr lang="en-US" sz="900" dirty="0"/>
+          </a:p>
+        </p:txBody>
+      </p:sp>
+      <p:sp>
+        <p:nvSpPr>
+          <p:cNvPr id="37" name="Shape 34"/>
+          <p:cNvSpPr/>
+          <p:nvPr/>
+        </p:nvSpPr>
+        <p:spPr>
+          <a:xfrm>
+            <a:off x="9107424" y="4690872"/>
+            <a:ext cx="2523744" cy="873252"/>
           </a:xfrm>
           <a:prstGeom prst="roundRect">
             <a:avLst>
-              <a:gd name="adj" fmla="val 20000"/>
+              <a:gd name="adj" fmla="val 9424"/>
             </a:avLst>
           </a:prstGeom>
           <a:solidFill>
-            <a:srgbClr val="0B1C39"/>
+            <a:srgbClr val="0C1F40"/>
           </a:solidFill>
           <a:ln w="12700">
             <a:solidFill>
@@ -9509,7 +9474,105 @@
       </p:sp>
       <p:sp>
         <p:nvSpPr>
-          <p:cNvPr id="39" name="Text 37"/>
+          <p:cNvPr id="38" name="Shape 35"/>
+          <p:cNvSpPr/>
+          <p:nvPr/>
+        </p:nvSpPr>
+        <p:spPr>
+          <a:xfrm>
+            <a:off x="9272016" y="4837176"/>
+            <a:ext cx="384048" cy="50292"/>
+          </a:xfrm>
+          <a:prstGeom prst="rect">
+            <a:avLst/>
+          </a:prstGeom>
+          <a:solidFill>
+            <a:srgbClr val="0E9488"/>
+          </a:solidFill>
+          <a:ln/>
+        </p:spPr>
+      </p:sp>
+      <p:sp>
+        <p:nvSpPr>
+          <p:cNvPr id="39" name="Text 36"/>
+          <p:cNvSpPr/>
+          <p:nvPr/>
+        </p:nvSpPr>
+        <p:spPr>
+          <a:xfrm>
+            <a:off x="9272016" y="4928616"/>
+            <a:ext cx="2194560" cy="237744"/>
+          </a:xfrm>
+          <a:prstGeom prst="rect">
+            <a:avLst/>
+          </a:prstGeom>
+          <a:noFill/>
+          <a:ln/>
+        </p:spPr>
+        <p:txBody>
+          <a:bodyPr wrap="square" rtlCol="0" anchor="ctr"/>
+          <a:lstStyle/>
+          <a:p>
+            <a:pPr indent="0" marL="0">
+              <a:buNone/>
+            </a:pPr>
+            <a:r>
+              <a:rPr lang="en-US" sz="1200" b="1" dirty="0">
+                <a:solidFill>
+                  <a:srgbClr val="F5F0E6"/>
+                </a:solidFill>
+                <a:latin typeface="Calibri" pitchFamily="34" charset="0"/>
+                <a:ea typeface="Calibri" pitchFamily="34" charset="-122"/>
+                <a:cs typeface="Calibri" pitchFamily="34" charset="-120"/>
+              </a:rPr>
+              <a:t>AI Insights</a:t>
+            </a:r>
+            <a:endParaRPr lang="en-US" sz="1200" dirty="0"/>
+          </a:p>
+        </p:txBody>
+      </p:sp>
+      <p:sp>
+        <p:nvSpPr>
+          <p:cNvPr id="40" name="Text 37"/>
+          <p:cNvSpPr/>
+          <p:nvPr/>
+        </p:nvSpPr>
+        <p:spPr>
+          <a:xfrm>
+            <a:off x="9272016" y="5175504"/>
+            <a:ext cx="2194560" cy="365760"/>
+          </a:xfrm>
+          <a:prstGeom prst="rect">
+            <a:avLst/>
+          </a:prstGeom>
+          <a:noFill/>
+          <a:ln/>
+        </p:spPr>
+        <p:txBody>
+          <a:bodyPr wrap="square" rtlCol="0" anchor="t"/>
+          <a:lstStyle/>
+          <a:p>
+            <a:pPr indent="0" marL="0">
+              <a:buNone/>
+            </a:pPr>
+            <a:r>
+              <a:rPr lang="en-US" sz="900" dirty="0">
+                <a:solidFill>
+                  <a:srgbClr val="C7D2E4"/>
+                </a:solidFill>
+                <a:latin typeface="Calibri" pitchFamily="34" charset="0"/>
+                <a:ea typeface="Calibri" pitchFamily="34" charset="-122"/>
+                <a:cs typeface="Calibri" pitchFamily="34" charset="-120"/>
+              </a:rPr>
+              <a:t>Business intelligence grounded in your own numbers.</a:t>
+            </a:r>
+            <a:endParaRPr lang="en-US" sz="900" dirty="0"/>
+          </a:p>
+        </p:txBody>
+      </p:sp>
+      <p:sp>
+        <p:nvSpPr>
+          <p:cNvPr id="41" name="Shape 38"/>
           <p:cNvSpPr/>
           <p:nvPr/>
         </p:nvSpPr>
@@ -9518,6 +9581,33 @@
             <a:off x="502920" y="5852160"/>
             <a:ext cx="11128248" cy="457200"/>
           </a:xfrm>
+          <a:prstGeom prst="roundRect">
+            <a:avLst>
+              <a:gd name="adj" fmla="val 20000"/>
+            </a:avLst>
+          </a:prstGeom>
+          <a:solidFill>
+            <a:srgbClr val="0B1C39"/>
+          </a:solidFill>
+          <a:ln w="12700">
+            <a:solidFill>
+              <a:srgbClr val="1E3A63"/>
+            </a:solidFill>
+            <a:prstDash val="solid"/>
+          </a:ln>
+        </p:spPr>
+      </p:sp>
+      <p:sp>
+        <p:nvSpPr>
+          <p:cNvPr id="42" name="Text 39"/>
+          <p:cNvSpPr/>
+          <p:nvPr/>
+        </p:nvSpPr>
+        <p:spPr>
+          <a:xfrm>
+            <a:off x="502920" y="5852160"/>
+            <a:ext cx="11128248" cy="457200"/>
+          </a:xfrm>
           <a:prstGeom prst="rect">
             <a:avLst/>
           </a:prstGeom>
@@ -9548,7 +9638,7 @@
       </p:sp>
       <p:sp>
         <p:nvSpPr>
-          <p:cNvPr id="40" name="Shape 38"/>
+          <p:cNvPr id="43" name="Shape 40"/>
           <p:cNvSpPr/>
           <p:nvPr/>
         </p:nvSpPr>
@@ -9568,7 +9658,7 @@
       </p:sp>
       <p:sp>
         <p:nvSpPr>
-          <p:cNvPr id="41" name="Text 39"/>
+          <p:cNvPr id="44" name="Text 41"/>
           <p:cNvSpPr/>
           <p:nvPr/>
         </p:nvSpPr>
@@ -9607,7 +9697,7 @@
       </p:sp>
       <p:sp>
         <p:nvSpPr>
-          <p:cNvPr id="42" name="Text 40"/>
+          <p:cNvPr id="45" name="Text 42"/>
           <p:cNvSpPr/>
           <p:nvPr/>
         </p:nvSpPr>
@@ -10034,16 +10124,16 @@
         </p:nvSpPr>
         <p:spPr>
           <a:xfrm>
-            <a:off x="6172200" y="1481328"/>
-            <a:ext cx="5458968" cy="4370832"/>
+            <a:off x="6126480" y="1435608"/>
+            <a:ext cx="5550408" cy="2422838"/>
           </a:xfrm>
           <a:prstGeom prst="roundRect">
             <a:avLst>
-              <a:gd name="adj" fmla="val 1883"/>
+              <a:gd name="adj" fmla="val 3397"/>
             </a:avLst>
           </a:prstGeom>
           <a:solidFill>
-            <a:srgbClr val="0B1C39"/>
+            <a:srgbClr val="102542"/>
           </a:solidFill>
           <a:ln w="12700">
             <a:solidFill>
@@ -10053,16 +10143,67 @@
           </a:ln>
         </p:spPr>
       </p:sp>
-      <p:sp>
-        <p:nvSpPr>
-          <p:cNvPr id="14" name="Text 12"/>
-          <p:cNvSpPr/>
-          <p:nvPr/>
-        </p:nvSpPr>
-        <p:spPr>
-          <a:xfrm>
-            <a:off x="6446520" y="1700784"/>
-            <a:ext cx="4937760" cy="384048"/>
+      <p:pic>
+        <p:nvPicPr>
+          <p:cNvPr id="14" name="Image 0" descr="C:/Users/ZBOOK/AppData/Local/Temp/kazi-deck/assets/shot-billing-crop.png">    </p:cNvPr>
+          <p:cNvPicPr>
+            <a:picLocks noChangeAspect="1"/>
+          </p:cNvPicPr>
+          <p:nvPr/>
+        </p:nvPicPr>
+        <p:blipFill>
+          <a:blip r:embed="rId1"/>
+          <a:stretch>
+            <a:fillRect/>
+          </a:stretch>
+        </p:blipFill>
+        <p:spPr>
+          <a:xfrm>
+            <a:off x="6172200" y="1481328"/>
+            <a:ext cx="5458968" cy="2331398"/>
+          </a:xfrm>
+          <a:prstGeom prst="rect">
+            <a:avLst/>
+          </a:prstGeom>
+        </p:spPr>
+      </p:pic>
+      <p:sp>
+        <p:nvSpPr>
+          <p:cNvPr id="15" name="Shape 12"/>
+          <p:cNvSpPr/>
+          <p:nvPr/>
+        </p:nvSpPr>
+        <p:spPr>
+          <a:xfrm>
+            <a:off x="6172200" y="3949886"/>
+            <a:ext cx="5458968" cy="1902274"/>
+          </a:xfrm>
+          <a:prstGeom prst="roundRect">
+            <a:avLst>
+              <a:gd name="adj" fmla="val 4326"/>
+            </a:avLst>
+          </a:prstGeom>
+          <a:solidFill>
+            <a:srgbClr val="0B1C39"/>
+          </a:solidFill>
+          <a:ln w="12700">
+            <a:solidFill>
+              <a:srgbClr val="1E3A63"/>
+            </a:solidFill>
+            <a:prstDash val="solid"/>
+          </a:ln>
+        </p:spPr>
+      </p:sp>
+      <p:sp>
+        <p:nvSpPr>
+          <p:cNvPr id="16" name="Text 13"/>
+          <p:cNvSpPr/>
+          <p:nvPr/>
+        </p:nvSpPr>
+        <p:spPr>
+          <a:xfrm>
+            <a:off x="6446520" y="4096190"/>
+            <a:ext cx="4910328" cy="329184"/>
           </a:xfrm>
           <a:prstGeom prst="rect">
             <a:avLst/>
@@ -10078,7 +10219,7 @@
               <a:buNone/>
             </a:pPr>
             <a:r>
-              <a:rPr lang="en-US" sz="1700" b="1" dirty="0">
+              <a:rPr lang="en-US" sz="1600" b="1" dirty="0">
                 <a:solidFill>
                   <a:srgbClr val="F5A314"/>
                 </a:solidFill>
@@ -10088,20 +10229,20 @@
               </a:rPr>
               <a:t>Why it is trustworthy</a:t>
             </a:r>
-            <a:endParaRPr lang="en-US" sz="1700" dirty="0"/>
-          </a:p>
-        </p:txBody>
-      </p:sp>
-      <p:sp>
-        <p:nvSpPr>
-          <p:cNvPr id="15" name="Text 13"/>
-          <p:cNvSpPr/>
-          <p:nvPr/>
-        </p:nvSpPr>
-        <p:spPr>
-          <a:xfrm>
-            <a:off x="6446520" y="2194560"/>
-            <a:ext cx="4937760" cy="3474720"/>
+            <a:endParaRPr lang="en-US" sz="1600" dirty="0"/>
+          </a:p>
+        </p:txBody>
+      </p:sp>
+      <p:sp>
+        <p:nvSpPr>
+          <p:cNvPr id="17" name="Text 14"/>
+          <p:cNvSpPr/>
+          <p:nvPr/>
+        </p:nvSpPr>
+        <p:spPr>
+          <a:xfrm>
+            <a:off x="6446520" y="4461950"/>
+            <a:ext cx="4910328" cy="1280482"/>
           </a:xfrm>
           <a:prstGeom prst="rect">
             <a:avLst/>
@@ -10121,7 +10262,7 @@
               <a:buChar char="•"/>
             </a:pPr>
             <a:r>
-              <a:rPr lang="en-US" sz="1300" dirty="0">
+              <a:rPr lang="en-US" sz="1250" dirty="0">
                 <a:solidFill>
                   <a:srgbClr val="C7D2E4"/>
                 </a:solidFill>
@@ -10131,7 +10272,7 @@
               </a:rPr>
               <a:t>Amount checked against the plan price — every time</a:t>
             </a:r>
-            <a:endParaRPr lang="en-US" sz="1300" dirty="0"/>
+            <a:endParaRPr lang="en-US" sz="1250" dirty="0"/>
           </a:p>
           <a:p>
             <a:pPr marL="342900" indent="-342900">
@@ -10142,7 +10283,7 @@
               <a:buChar char="•"/>
             </a:pPr>
             <a:r>
-              <a:rPr lang="en-US" sz="1300" dirty="0">
+              <a:rPr lang="en-US" sz="1250" dirty="0">
                 <a:solidFill>
                   <a:srgbClr val="C7D2E4"/>
                 </a:solidFill>
@@ -10152,7 +10293,7 @@
               </a:rPr>
               <a:t>Idempotent activation: one payment, one grant, ever</a:t>
             </a:r>
-            <a:endParaRPr lang="en-US" sz="1300" dirty="0"/>
+            <a:endParaRPr lang="en-US" sz="1250" dirty="0"/>
           </a:p>
           <a:p>
             <a:pPr marL="342900" indent="-342900">
@@ -10163,7 +10304,7 @@
               <a:buChar char="•"/>
             </a:pPr>
             <a:r>
-              <a:rPr lang="en-US" sz="1300" dirty="0">
+              <a:rPr lang="en-US" sz="1250" dirty="0">
                 <a:solidFill>
                   <a:srgbClr val="C7D2E4"/>
                 </a:solidFill>
@@ -10173,7 +10314,7 @@
               </a:rPr>
               <a:t>Unsigned webhook can only trigger a verification query</a:t>
             </a:r>
-            <a:endParaRPr lang="en-US" sz="1300" dirty="0"/>
+            <a:endParaRPr lang="en-US" sz="1250" dirty="0"/>
           </a:p>
           <a:p>
             <a:pPr marL="342900" indent="-342900">
@@ -10184,7 +10325,7 @@
               <a:buChar char="•"/>
             </a:pPr>
             <a:r>
-              <a:rPr lang="en-US" sz="1300" dirty="0">
+              <a:rPr lang="en-US" sz="1250" dirty="0">
                 <a:solidFill>
                   <a:srgbClr val="C7D2E4"/>
                 </a:solidFill>
@@ -10194,55 +10335,13 @@
               </a:rPr>
               <a:t>Rate-limit aware: undecided payments poll politely, then retry</a:t>
             </a:r>
-            <a:endParaRPr lang="en-US" sz="1300" dirty="0"/>
-          </a:p>
-          <a:p>
-            <a:pPr marL="342900" indent="-342900">
-              <a:spcAft>
-                <a:spcPts val="700"/>
-              </a:spcAft>
-              <a:buSzPct val="100000"/>
-              <a:buChar char="•"/>
-            </a:pPr>
-            <a:r>
-              <a:rPr lang="en-US" sz="1300" dirty="0">
-                <a:solidFill>
-                  <a:srgbClr val="C7D2E4"/>
-                </a:solidFill>
-                <a:latin typeface="Calibri" pitchFamily="34" charset="0"/>
-                <a:ea typeface="Calibri" pitchFamily="34" charset="-122"/>
-                <a:cs typeface="Calibri" pitchFamily="34" charset="-120"/>
-              </a:rPr>
-              <a:t>Free plan and paid plans, monthly or annual, one engine</a:t>
-            </a:r>
-            <a:endParaRPr lang="en-US" sz="1300" dirty="0"/>
-          </a:p>
-          <a:p>
-            <a:pPr marL="342900" indent="-342900">
-              <a:spcAft>
-                <a:spcPts val="700"/>
-              </a:spcAft>
-              <a:buSzPct val="100000"/>
-              <a:buChar char="•"/>
-            </a:pPr>
-            <a:r>
-              <a:rPr lang="en-US" sz="1300" dirty="0">
-                <a:solidFill>
-                  <a:srgbClr val="C7D2E4"/>
-                </a:solidFill>
-                <a:latin typeface="Calibri" pitchFamily="34" charset="0"/>
-                <a:ea typeface="Calibri" pitchFamily="34" charset="-122"/>
-                <a:cs typeface="Calibri" pitchFamily="34" charset="-120"/>
-              </a:rPr>
-              <a:t>Billing portal: invoices, receipts, plan changes</a:t>
-            </a:r>
-            <a:endParaRPr lang="en-US" sz="1300" dirty="0"/>
-          </a:p>
-        </p:txBody>
-      </p:sp>
-      <p:sp>
-        <p:nvSpPr>
-          <p:cNvPr id="16" name="Shape 14"/>
+            <a:endParaRPr lang="en-US" sz="1250" dirty="0"/>
+          </a:p>
+        </p:txBody>
+      </p:sp>
+      <p:sp>
+        <p:nvSpPr>
+          <p:cNvPr id="18" name="Shape 15"/>
           <p:cNvSpPr/>
           <p:nvPr/>
         </p:nvSpPr>
@@ -10264,7 +10363,7 @@
       </p:sp>
       <p:sp>
         <p:nvSpPr>
-          <p:cNvPr id="17" name="Text 15"/>
+          <p:cNvPr id="19" name="Text 16"/>
           <p:cNvSpPr/>
           <p:nvPr/>
         </p:nvSpPr>
@@ -10303,7 +10402,7 @@
       </p:sp>
       <p:sp>
         <p:nvSpPr>
-          <p:cNvPr id="18" name="Shape 16"/>
+          <p:cNvPr id="20" name="Shape 17"/>
           <p:cNvSpPr/>
           <p:nvPr/>
         </p:nvSpPr>
@@ -10323,7 +10422,7 @@
       </p:sp>
       <p:sp>
         <p:nvSpPr>
-          <p:cNvPr id="19" name="Text 17"/>
+          <p:cNvPr id="21" name="Text 18"/>
           <p:cNvSpPr/>
           <p:nvPr/>
         </p:nvSpPr>
@@ -10362,7 +10461,7 @@
       </p:sp>
       <p:sp>
         <p:nvSpPr>
-          <p:cNvPr id="20" name="Text 18"/>
+          <p:cNvPr id="22" name="Text 19"/>
           <p:cNvSpPr/>
           <p:nvPr/>
         </p:nvSpPr>
@@ -11830,11 +11929,11 @@
         <p:spPr>
           <a:xfrm>
             <a:off x="7040880" y="1417320"/>
-            <a:ext cx="4590288" cy="4645152"/>
+            <a:ext cx="4590288" cy="4471416"/>
           </a:xfrm>
           <a:prstGeom prst="roundRect">
             <a:avLst>
-              <a:gd name="adj" fmla="val 1793"/>
+              <a:gd name="adj" fmla="val 1840"/>
             </a:avLst>
           </a:prstGeom>
           <a:solidFill>
@@ -11980,7 +12079,7 @@
         </p:nvSpPr>
         <p:spPr>
           <a:xfrm>
-            <a:off x="7315200" y="4224528"/>
+            <a:off x="7315200" y="3977640"/>
             <a:ext cx="4023360" cy="365760"/>
           </a:xfrm>
           <a:prstGeom prst="rect">
@@ -12019,7 +12118,7 @@
         </p:nvSpPr>
         <p:spPr>
           <a:xfrm>
-            <a:off x="7315200" y="4626864"/>
+            <a:off x="7315200" y="4379976"/>
             <a:ext cx="4069080" cy="1371600"/>
           </a:xfrm>
           <a:prstGeom prst="rect">
@@ -12579,11 +12678,11 @@
         <p:spPr>
           <a:xfrm>
             <a:off x="502920" y="1828800"/>
-            <a:ext cx="5486400" cy="4206240"/>
+            <a:ext cx="3611880" cy="3520440"/>
           </a:xfrm>
           <a:prstGeom prst="roundRect">
             <a:avLst>
-              <a:gd name="adj" fmla="val 1957"/>
+              <a:gd name="adj" fmla="val 2338"/>
             </a:avLst>
           </a:prstGeom>
           <a:solidFill>
@@ -12605,7 +12704,7 @@
         </p:nvSpPr>
         <p:spPr>
           <a:xfrm>
-            <a:off x="795528" y="2066544"/>
+            <a:off x="758952" y="2066544"/>
             <a:ext cx="1463040" cy="310896"/>
           </a:xfrm>
           <a:prstGeom prst="roundRect">
@@ -12627,7 +12726,7 @@
         </p:nvSpPr>
         <p:spPr>
           <a:xfrm>
-            <a:off x="795528" y="2066544"/>
+            <a:off x="758952" y="2066544"/>
             <a:ext cx="1463040" cy="310896"/>
           </a:xfrm>
           <a:prstGeom prst="rect">
@@ -12666,8 +12765,8 @@
         </p:nvSpPr>
         <p:spPr>
           <a:xfrm>
-            <a:off x="795528" y="2523744"/>
-            <a:ext cx="4937760" cy="3383280"/>
+            <a:off x="758952" y="2523744"/>
+            <a:ext cx="3099816" cy="2697480"/>
           </a:xfrm>
           <a:prstGeom prst="rect">
             <a:avLst/>
@@ -12687,7 +12786,7 @@
               <a:buChar char="•"/>
             </a:pPr>
             <a:r>
-              <a:rPr lang="en-US" sz="1300" dirty="0">
+              <a:rPr lang="en-US" sz="1100" dirty="0">
                 <a:solidFill>
                   <a:srgbClr val="C7D2E4"/>
                 </a:solidFill>
@@ -12697,7 +12796,7 @@
               </a:rPr>
               <a:t>Authentication, organizations, roles &amp; audit logging</a:t>
             </a:r>
-            <a:endParaRPr lang="en-US" sz="1300" dirty="0"/>
+            <a:endParaRPr lang="en-US" sz="1100" dirty="0"/>
           </a:p>
           <a:p>
             <a:pPr marL="342900" indent="-342900">
@@ -12708,7 +12807,7 @@
               <a:buChar char="•"/>
             </a:pPr>
             <a:r>
-              <a:rPr lang="en-US" sz="1300" dirty="0">
+              <a:rPr lang="en-US" sz="1100" dirty="0">
                 <a:solidFill>
                   <a:srgbClr val="C7D2E4"/>
                 </a:solidFill>
@@ -12718,7 +12817,7 @@
               </a:rPr>
               <a:t>Products, customers, invoices, payments</a:t>
             </a:r>
-            <a:endParaRPr lang="en-US" sz="1300" dirty="0"/>
+            <a:endParaRPr lang="en-US" sz="1100" dirty="0"/>
           </a:p>
           <a:p>
             <a:pPr marL="342900" indent="-342900">
@@ -12729,7 +12828,7 @@
               <a:buChar char="•"/>
             </a:pPr>
             <a:r>
-              <a:rPr lang="en-US" sz="1300" dirty="0">
+              <a:rPr lang="en-US" sz="1100" dirty="0">
                 <a:solidFill>
                   <a:srgbClr val="C7D2E4"/>
                 </a:solidFill>
@@ -12739,7 +12838,7 @@
               </a:rPr>
               <a:t>Branches, warehouses, settings, notifications</a:t>
             </a:r>
-            <a:endParaRPr lang="en-US" sz="1300" dirty="0"/>
+            <a:endParaRPr lang="en-US" sz="1100" dirty="0"/>
           </a:p>
           <a:p>
             <a:pPr marL="342900" indent="-342900">
@@ -12750,7 +12849,7 @@
               <a:buChar char="•"/>
             </a:pPr>
             <a:r>
-              <a:rPr lang="en-US" sz="1300" dirty="0">
+              <a:rPr lang="en-US" sz="1100" dirty="0">
                 <a:solidFill>
                   <a:srgbClr val="C7D2E4"/>
                 </a:solidFill>
@@ -12760,7 +12859,7 @@
               </a:rPr>
               <a:t>POS foundation and reporting foundation</a:t>
             </a:r>
-            <a:endParaRPr lang="en-US" sz="1300" dirty="0"/>
+            <a:endParaRPr lang="en-US" sz="1100" dirty="0"/>
           </a:p>
           <a:p>
             <a:pPr marL="342900" indent="-342900">
@@ -12771,7 +12870,7 @@
               <a:buChar char="•"/>
             </a:pPr>
             <a:r>
-              <a:rPr lang="en-US" sz="1300" dirty="0">
+              <a:rPr lang="en-US" sz="1100" dirty="0">
                 <a:solidFill>
                   <a:srgbClr val="C7D2E4"/>
                 </a:solidFill>
@@ -12781,7 +12880,7 @@
               </a:rPr>
               <a:t>Subscription plans, free tier, feature entitlements</a:t>
             </a:r>
-            <a:endParaRPr lang="en-US" sz="1300" dirty="0"/>
+            <a:endParaRPr lang="en-US" sz="1100" dirty="0"/>
           </a:p>
           <a:p>
             <a:pPr marL="342900" indent="-342900">
@@ -12792,7 +12891,7 @@
               <a:buChar char="•"/>
             </a:pPr>
             <a:r>
-              <a:rPr lang="en-US" sz="1300" dirty="0">
+              <a:rPr lang="en-US" sz="1100" dirty="0">
                 <a:solidFill>
                   <a:srgbClr val="C7D2E4"/>
                 </a:solidFill>
@@ -12802,7 +12901,7 @@
               </a:rPr>
               <a:t>Paystack + M-PESA payment rails, billing portal</a:t>
             </a:r>
-            <a:endParaRPr lang="en-US" sz="1300" dirty="0"/>
+            <a:endParaRPr lang="en-US" sz="1100" dirty="0"/>
           </a:p>
           <a:p>
             <a:pPr marL="342900" indent="-342900">
@@ -12813,7 +12912,7 @@
               <a:buChar char="•"/>
             </a:pPr>
             <a:r>
-              <a:rPr lang="en-US" sz="1300" dirty="0">
+              <a:rPr lang="en-US" sz="1100" dirty="0">
                 <a:solidFill>
                   <a:srgbClr val="C7D2E4"/>
                 </a:solidFill>
@@ -12823,7 +12922,7 @@
               </a:rPr>
               <a:t>Docs: architecture, subscriptions, M-PESA walkthrough</a:t>
             </a:r>
-            <a:endParaRPr lang="en-US" sz="1300" dirty="0"/>
+            <a:endParaRPr lang="en-US" sz="1100" dirty="0"/>
           </a:p>
         </p:txBody>
       </p:sp>
@@ -12835,12 +12934,12 @@
         </p:nvSpPr>
         <p:spPr>
           <a:xfrm>
-            <a:off x="6172200" y="1828800"/>
-            <a:ext cx="5458968" cy="4206240"/>
+            <a:off x="4343400" y="1828800"/>
+            <a:ext cx="3611880" cy="3520440"/>
           </a:xfrm>
           <a:prstGeom prst="roundRect">
             <a:avLst>
-              <a:gd name="adj" fmla="val 1957"/>
+              <a:gd name="adj" fmla="val 2338"/>
             </a:avLst>
           </a:prstGeom>
           <a:solidFill>
@@ -12862,7 +12961,7 @@
         </p:nvSpPr>
         <p:spPr>
           <a:xfrm>
-            <a:off x="6464808" y="2066544"/>
+            <a:off x="4599432" y="2066544"/>
             <a:ext cx="1737360" cy="310896"/>
           </a:xfrm>
           <a:prstGeom prst="roundRect">
@@ -12884,7 +12983,7 @@
         </p:nvSpPr>
         <p:spPr>
           <a:xfrm>
-            <a:off x="6464808" y="2066544"/>
+            <a:off x="4599432" y="2066544"/>
             <a:ext cx="1737360" cy="310896"/>
           </a:xfrm>
           <a:prstGeom prst="rect">
@@ -12923,8 +13022,8 @@
         </p:nvSpPr>
         <p:spPr>
           <a:xfrm>
-            <a:off x="6464808" y="2523744"/>
-            <a:ext cx="4937760" cy="3383280"/>
+            <a:off x="4599432" y="2523744"/>
+            <a:ext cx="3099816" cy="2697480"/>
           </a:xfrm>
           <a:prstGeom prst="rect">
             <a:avLst/>
@@ -12944,7 +13043,7 @@
               <a:buChar char="•"/>
             </a:pPr>
             <a:r>
-              <a:rPr lang="en-US" sz="1300" dirty="0">
+              <a:rPr lang="en-US" sz="1100" dirty="0">
                 <a:solidFill>
                   <a:srgbClr val="C7D2E4"/>
                 </a:solidFill>
@@ -12954,7 +13053,7 @@
               </a:rPr>
               <a:t>Complete cashier workflow &amp; barcode scanning</a:t>
             </a:r>
-            <a:endParaRPr lang="en-US" sz="1300" dirty="0"/>
+            <a:endParaRPr lang="en-US" sz="1100" dirty="0"/>
           </a:p>
           <a:p>
             <a:pPr marL="342900" indent="-342900">
@@ -12965,7 +13064,7 @@
               <a:buChar char="•"/>
             </a:pPr>
             <a:r>
-              <a:rPr lang="en-US" sz="1300" dirty="0">
+              <a:rPr lang="en-US" sz="1100" dirty="0">
                 <a:solidFill>
                   <a:srgbClr val="C7D2E4"/>
                 </a:solidFill>
@@ -12975,7 +13074,7 @@
               </a:rPr>
               <a:t>Returns, refunds, split payments, cashier shifts</a:t>
             </a:r>
-            <a:endParaRPr lang="en-US" sz="1300" dirty="0"/>
+            <a:endParaRPr lang="en-US" sz="1100" dirty="0"/>
           </a:p>
           <a:p>
             <a:pPr marL="342900" indent="-342900">
@@ -12986,7 +13085,7 @@
               <a:buChar char="•"/>
             </a:pPr>
             <a:r>
-              <a:rPr lang="en-US" sz="1300" dirty="0">
+              <a:rPr lang="en-US" sz="1100" dirty="0">
                 <a:solidFill>
                   <a:srgbClr val="C7D2E4"/>
                 </a:solidFill>
@@ -12996,7 +13095,7 @@
               </a:rPr>
               <a:t>Inventory ledger, transfers &amp; stocktaking</a:t>
             </a:r>
-            <a:endParaRPr lang="en-US" sz="1300" dirty="0"/>
+            <a:endParaRPr lang="en-US" sz="1100" dirty="0"/>
           </a:p>
           <a:p>
             <a:pPr marL="342900" indent="-342900">
@@ -13007,7 +13106,7 @@
               <a:buChar char="•"/>
             </a:pPr>
             <a:r>
-              <a:rPr lang="en-US" sz="1300" dirty="0">
+              <a:rPr lang="en-US" sz="1100" dirty="0">
                 <a:solidFill>
                   <a:srgbClr val="C7D2E4"/>
                 </a:solidFill>
@@ -13017,7 +13116,7 @@
               </a:rPr>
               <a:t>Purchasing lifecycle &amp; supplier balances</a:t>
             </a:r>
-            <a:endParaRPr lang="en-US" sz="1300" dirty="0"/>
+            <a:endParaRPr lang="en-US" sz="1100" dirty="0"/>
           </a:p>
           <a:p>
             <a:pPr marL="342900" indent="-342900">
@@ -13028,7 +13127,7 @@
               <a:buChar char="•"/>
             </a:pPr>
             <a:r>
-              <a:rPr lang="en-US" sz="1300" dirty="0">
+              <a:rPr lang="en-US" sz="1100" dirty="0">
                 <a:solidFill>
                   <a:srgbClr val="C7D2E4"/>
                 </a:solidFill>
@@ -13038,7 +13137,7 @@
               </a:rPr>
               <a:t>Accounting core (GL, receivables/payables, P&amp;L)</a:t>
             </a:r>
-            <a:endParaRPr lang="en-US" sz="1300" dirty="0"/>
+            <a:endParaRPr lang="en-US" sz="1100" dirty="0"/>
           </a:p>
           <a:p>
             <a:pPr marL="342900" indent="-342900">
@@ -13049,7 +13148,7 @@
               <a:buChar char="•"/>
             </a:pPr>
             <a:r>
-              <a:rPr lang="en-US" sz="1300" dirty="0">
+              <a:rPr lang="en-US" sz="1100" dirty="0">
                 <a:solidFill>
                   <a:srgbClr val="C7D2E4"/>
                 </a:solidFill>
@@ -13059,7 +13158,7 @@
               </a:rPr>
               <a:t>AI business copilot across every module</a:t>
             </a:r>
-            <a:endParaRPr lang="en-US" sz="1300" dirty="0"/>
+            <a:endParaRPr lang="en-US" sz="1100" dirty="0"/>
           </a:p>
           <a:p>
             <a:pPr marL="342900" indent="-342900">
@@ -13070,7 +13169,7 @@
               <a:buChar char="•"/>
             </a:pPr>
             <a:r>
-              <a:rPr lang="en-US" sz="1300" dirty="0">
+              <a:rPr lang="en-US" sz="1100" dirty="0">
                 <a:solidFill>
                   <a:srgbClr val="C7D2E4"/>
                 </a:solidFill>
@@ -13080,13 +13179,169 @@
               </a:rPr>
               <a:t>Offline POS · KRA eTIMS · WhatsApp &amp; SMS</a:t>
             </a:r>
-            <a:endParaRPr lang="en-US" sz="1300" dirty="0"/>
+            <a:endParaRPr lang="en-US" sz="1100" dirty="0"/>
           </a:p>
         </p:txBody>
       </p:sp>
       <p:sp>
         <p:nvSpPr>
           <p:cNvPr id="21" name="Shape 19"/>
+          <p:cNvSpPr/>
+          <p:nvPr/>
+        </p:nvSpPr>
+        <p:spPr>
+          <a:xfrm>
+            <a:off x="8138160" y="1783080"/>
+            <a:ext cx="3538728" cy="2245995"/>
+          </a:xfrm>
+          <a:prstGeom prst="roundRect">
+            <a:avLst>
+              <a:gd name="adj" fmla="val 3664"/>
+            </a:avLst>
+          </a:prstGeom>
+          <a:solidFill>
+            <a:srgbClr val="102542"/>
+          </a:solidFill>
+          <a:ln w="12700">
+            <a:solidFill>
+              <a:srgbClr val="1E3A63"/>
+            </a:solidFill>
+            <a:prstDash val="solid"/>
+          </a:ln>
+        </p:spPr>
+      </p:sp>
+      <p:pic>
+        <p:nvPicPr>
+          <p:cNvPr id="22" name="Image 0" descr="C:/Users/ZBOOK/AppData/Local/Temp/kazi-deck/assets/shot-dashboard.png">    </p:cNvPr>
+          <p:cNvPicPr>
+            <a:picLocks noChangeAspect="1"/>
+          </p:cNvPicPr>
+          <p:nvPr/>
+        </p:nvPicPr>
+        <p:blipFill>
+          <a:blip r:embed="rId1"/>
+          <a:stretch>
+            <a:fillRect/>
+          </a:stretch>
+        </p:blipFill>
+        <p:spPr>
+          <a:xfrm>
+            <a:off x="8183880" y="1828800"/>
+            <a:ext cx="3447288" cy="2154555"/>
+          </a:xfrm>
+          <a:prstGeom prst="rect">
+            <a:avLst/>
+          </a:prstGeom>
+        </p:spPr>
+      </p:pic>
+      <p:sp>
+        <p:nvSpPr>
+          <p:cNvPr id="23" name="Shape 20"/>
+          <p:cNvSpPr/>
+          <p:nvPr/>
+        </p:nvSpPr>
+        <p:spPr>
+          <a:xfrm>
+            <a:off x="8183880" y="4120515"/>
+            <a:ext cx="3447288" cy="1228725"/>
+          </a:xfrm>
+          <a:prstGeom prst="roundRect">
+            <a:avLst>
+              <a:gd name="adj" fmla="val 6698"/>
+            </a:avLst>
+          </a:prstGeom>
+          <a:solidFill>
+            <a:srgbClr val="0C1F40"/>
+          </a:solidFill>
+          <a:ln w="12700">
+            <a:solidFill>
+              <a:srgbClr val="1E3A63"/>
+            </a:solidFill>
+            <a:prstDash val="solid"/>
+          </a:ln>
+        </p:spPr>
+      </p:sp>
+      <p:sp>
+        <p:nvSpPr>
+          <p:cNvPr id="24" name="Text 21"/>
+          <p:cNvSpPr/>
+          <p:nvPr/>
+        </p:nvSpPr>
+        <p:spPr>
+          <a:xfrm>
+            <a:off x="8403336" y="4266819"/>
+            <a:ext cx="3008376" cy="292608"/>
+          </a:xfrm>
+          <a:prstGeom prst="rect">
+            <a:avLst/>
+          </a:prstGeom>
+          <a:noFill/>
+          <a:ln/>
+        </p:spPr>
+        <p:txBody>
+          <a:bodyPr wrap="square" rtlCol="0" anchor="ctr"/>
+          <a:lstStyle/>
+          <a:p>
+            <a:pPr indent="0" marL="0">
+              <a:buNone/>
+            </a:pPr>
+            <a:r>
+              <a:rPr lang="en-US" sz="1400" b="1" dirty="0">
+                <a:solidFill>
+                  <a:srgbClr val="F5A314"/>
+                </a:solidFill>
+                <a:latin typeface="Calibri" pitchFamily="34" charset="0"/>
+                <a:ea typeface="Calibri" pitchFamily="34" charset="-122"/>
+                <a:cs typeface="Calibri" pitchFamily="34" charset="-120"/>
+              </a:rPr>
+              <a:t>In production today</a:t>
+            </a:r>
+            <a:endParaRPr lang="en-US" sz="1400" dirty="0"/>
+          </a:p>
+        </p:txBody>
+      </p:sp>
+      <p:sp>
+        <p:nvSpPr>
+          <p:cNvPr id="25" name="Text 22"/>
+          <p:cNvSpPr/>
+          <p:nvPr/>
+        </p:nvSpPr>
+        <p:spPr>
+          <a:xfrm>
+            <a:off x="8403336" y="4614291"/>
+            <a:ext cx="3008376" cy="960120"/>
+          </a:xfrm>
+          <a:prstGeom prst="rect">
+            <a:avLst/>
+          </a:prstGeom>
+          <a:noFill/>
+          <a:ln/>
+        </p:spPr>
+        <p:txBody>
+          <a:bodyPr wrap="square" rtlCol="0" anchor="t"/>
+          <a:lstStyle/>
+          <a:p>
+            <a:pPr indent="0" marL="0">
+              <a:buNone/>
+            </a:pPr>
+            <a:r>
+              <a:rPr lang="en-US" sz="1100" dirty="0">
+                <a:solidFill>
+                  <a:srgbClr val="C7D2E4"/>
+                </a:solidFill>
+                <a:latin typeface="Calibri" pitchFamily="34" charset="0"/>
+                <a:ea typeface="Calibri" pitchFamily="34" charset="-122"/>
+                <a:cs typeface="Calibri" pitchFamily="34" charset="-120"/>
+              </a:rPr>
+              <a:t>The live dashboard — real organisation data: KES 1.17M revenue this month, 151 sales, low-stock alerts and top products.</a:t>
+            </a:r>
+            <a:endParaRPr lang="en-US" sz="1100" dirty="0"/>
+          </a:p>
+        </p:txBody>
+      </p:sp>
+      <p:sp>
+        <p:nvSpPr>
+          <p:cNvPr id="26" name="Shape 23"/>
           <p:cNvSpPr/>
           <p:nvPr/>
         </p:nvSpPr>
@@ -13106,7 +13361,7 @@
       </p:sp>
       <p:sp>
         <p:nvSpPr>
-          <p:cNvPr id="22" name="Text 20"/>
+          <p:cNvPr id="27" name="Text 24"/>
           <p:cNvSpPr/>
           <p:nvPr/>
         </p:nvSpPr>
@@ -13145,7 +13400,7 @@
       </p:sp>
       <p:sp>
         <p:nvSpPr>
-          <p:cNvPr id="23" name="Text 21"/>
+          <p:cNvPr id="28" name="Text 25"/>
           <p:cNvSpPr/>
           <p:nvPr/>
         </p:nvSpPr>

</xml_diff>

<commit_message>
feat: complete plan-gated AI assistant and add Phase 1 read tools
- AI assistant backend: aiTools.ts (read-only tools), aiAssistant.ts
  (deterministic fallback + AI routing), routes/ai.ts (auth,
  reports.view feature gate, ai_requests metering)
- Frontend: AssistantPage chat UI, /assistant route, nav item
- Dashboard DOM fix: table always mounted, EmptyRow inside tbody
- Phase 1 read tools: cash_position, expense_summary, branch_stock,
  registered in TOOL_CATALOG and wired via runTool routing
- Tests: aiTools.test.ts + aiAssistant.test.ts (28/28 passing),
  tsc/eslint clean on changed files
</commit_message>
<xml_diff>
--- a/docs/presentation/KaziOS-Presentation.pptx
+++ b/docs/presentation/KaziOS-Presentation.pptx
@@ -4,6 +4,9 @@
   <p:sldMasterIdLst>
     <p:sldMasterId id="2147483648" r:id="rId1"/>
   </p:sldMasterIdLst>
+  <p:notesMasterIdLst>
+    <p:notesMasterId r:id="rId15"/>
+  </p:notesMasterIdLst>
   <p:sldIdLst>
     <p:sldId id="256" r:id="rId2"/>
     <p:sldId id="257" r:id="rId3"/>
@@ -19,9 +22,6 @@
     <p:sldId id="267" r:id="rId13"/>
     <p:sldId id="268" r:id="rId14"/>
   </p:sldIdLst>
-  <p:notesMasterIdLst>
-    <p:notesMasterId r:id="rId15"/>
-  </p:notesMasterIdLst>
   <p:sldSz cx="12192000" cy="6858000"/>
   <p:notesSz cx="6858000" cy="12192000"/>
   <p:defaultTextStyle>
@@ -116,6 +116,11 @@
       </a:defRPr>
     </a:lvl9pPr>
   </p:defaultTextStyle>
+  <p:extLst>
+    <p:ext uri="{EFAFB233-063F-42B5-8137-9DF3F51BA10A}">
+      <p15:sldGuideLst xmlns:p15="http://schemas.microsoft.com/office/powerpoint/2012/main"/>
+    </p:ext>
+  </p:extLst>
 </p:presentation>
 </file>
 
@@ -141,234 +146,10 @@
           <a:chExt cx="0" cy="0"/>
         </a:xfrm>
       </p:grpSpPr>
-      <p:sp>
-        <p:nvSpPr>
-          <p:cNvPr id="2" name="Header Placeholder 1"/>
-          <p:cNvSpPr>
-            <a:spLocks noGrp="1"/>
-          </p:cNvSpPr>
-          <p:nvPr>
-            <p:ph type="hdr" sz="quarter"/>
-          </p:nvPr>
-        </p:nvSpPr>
-        <p:spPr>
-          <a:xfrm>
-            <a:off x="0" y="0"/>
-            <a:ext cx="2971800" cy="458788"/>
-          </a:xfrm>
-          <a:prstGeom prst="rect">
-            <a:avLst/>
-          </a:prstGeom>
-        </p:spPr>
-        <p:txBody>
-          <a:bodyPr vert="horz" lIns="91440" tIns="45720" rIns="91440" bIns="45720" rtlCol="0"/>
-          <a:lstStyle>
-            <a:lvl1pPr algn="l">
-              <a:defRPr sz="1200"/>
-            </a:lvl1pPr>
-          </a:lstStyle>
-          <a:p>
-            <a:endParaRPr lang="en-US"/>
-          </a:p>
-        </p:txBody>
-      </p:sp>
-      <p:sp>
-        <p:nvSpPr>
-          <p:cNvPr id="3" name="Date Placeholder 2"/>
-          <p:cNvSpPr>
-            <a:spLocks noGrp="1"/>
-          </p:cNvSpPr>
-          <p:nvPr>
-            <p:ph type="dt" idx="1"/>
-          </p:nvPr>
-        </p:nvSpPr>
-        <p:spPr>
-          <a:xfrm>
-            <a:off x="3884613" y="0"/>
-            <a:ext cx="2971800" cy="458788"/>
-          </a:xfrm>
-          <a:prstGeom prst="rect">
-            <a:avLst/>
-          </a:prstGeom>
-        </p:spPr>
-        <p:txBody>
-          <a:bodyPr vert="horz" lIns="91440" tIns="45720" rIns="91440" bIns="45720" rtlCol="0"/>
-          <a:lstStyle>
-            <a:lvl1pPr algn="r">
-              <a:defRPr sz="1200"/>
-            </a:lvl1pPr>
-          </a:lstStyle>
-          <a:p>
-            <a:fld id="{5282F153-3F37-0F45-9E97-73ACFA13230C}" type="datetimeFigureOut">
-              <a:rPr lang="en-US"/>
-              <a:t>7/23/19</a:t>
-            </a:fld>
-            <a:endParaRPr lang="en-US"/>
-          </a:p>
-        </p:txBody>
-      </p:sp>
-      <p:sp>
-        <p:nvSpPr>
-          <p:cNvPr id="4" name="Slide Image Placeholder 3"/>
-          <p:cNvSpPr>
-            <a:spLocks noGrp="1" noRot="1" noChangeAspect="1"/>
-          </p:cNvSpPr>
-          <p:nvPr>
-            <p:ph type="sldImg" idx="2"/>
-          </p:nvPr>
-        </p:nvSpPr>
-        <p:spPr>
-          <a:xfrm>
-            <a:off x="685800" y="1143000"/>
-            <a:ext cx="5486400" cy="3086100"/>
-          </a:xfrm>
-          <a:prstGeom prst="rect">
-            <a:avLst/>
-          </a:prstGeom>
-          <a:noFill/>
-          <a:ln w="12700">
-            <a:solidFill>
-              <a:prstClr val="black"/>
-            </a:solidFill>
-          </a:ln>
-        </p:spPr>
-        <p:txBody>
-          <a:bodyPr vert="horz" lIns="91440" tIns="45720" rIns="91440" bIns="45720" rtlCol="0" anchor="ctr"/>
-          <a:lstStyle/>
-          <a:p>
-            <a:endParaRPr lang="en-US"/>
-          </a:p>
-        </p:txBody>
-      </p:sp>
-      <p:sp>
-        <p:nvSpPr>
-          <p:cNvPr id="5" name="Notes Placeholder 4"/>
-          <p:cNvSpPr>
-            <a:spLocks noGrp="1"/>
-          </p:cNvSpPr>
-          <p:nvPr>
-            <p:ph type="body" sz="quarter" idx="3"/>
-          </p:nvPr>
-        </p:nvSpPr>
-        <p:spPr>
-          <a:xfrm>
-            <a:off x="685800" y="4400550"/>
-            <a:ext cx="5486400" cy="3600450"/>
-          </a:xfrm>
-          <a:prstGeom prst="rect">
-            <a:avLst/>
-          </a:prstGeom>
-        </p:spPr>
-        <p:txBody>
-          <a:bodyPr vert="horz" lIns="91440" tIns="45720" rIns="91440" bIns="45720" rtlCol="0"/>
-          <a:lstStyle/>
-          <a:p>
-            <a:pPr lvl="0"/>
-            <a:r>
-              <a:rPr lang="en-US"/>
-              <a:t>Click to edit Master text styles</a:t>
-            </a:r>
-          </a:p>
-          <a:p>
-            <a:pPr lvl="1"/>
-            <a:r>
-              <a:rPr lang="en-US"/>
-              <a:t>Second level</a:t>
-            </a:r>
-          </a:p>
-          <a:p>
-            <a:pPr lvl="2"/>
-            <a:r>
-              <a:rPr lang="en-US"/>
-              <a:t>Third level</a:t>
-            </a:r>
-          </a:p>
-          <a:p>
-            <a:pPr lvl="3"/>
-            <a:r>
-              <a:rPr lang="en-US"/>
-              <a:t>Fourth level</a:t>
-            </a:r>
-          </a:p>
-          <a:p>
-            <a:pPr lvl="4"/>
-            <a:r>
-              <a:rPr lang="en-US"/>
-              <a:t>Fifth level</a:t>
-            </a:r>
-          </a:p>
-        </p:txBody>
-      </p:sp>
-      <p:sp>
-        <p:nvSpPr>
-          <p:cNvPr id="6" name="Footer Placeholder 5"/>
-          <p:cNvSpPr>
-            <a:spLocks noGrp="1"/>
-          </p:cNvSpPr>
-          <p:nvPr>
-            <p:ph type="ftr" sz="quarter" idx="4"/>
-          </p:nvPr>
-        </p:nvSpPr>
-        <p:spPr>
-          <a:xfrm>
-            <a:off x="0" y="8685213"/>
-            <a:ext cx="2971800" cy="458787"/>
-          </a:xfrm>
-          <a:prstGeom prst="rect">
-            <a:avLst/>
-          </a:prstGeom>
-        </p:spPr>
-        <p:txBody>
-          <a:bodyPr vert="horz" lIns="91440" tIns="45720" rIns="91440" bIns="45720" rtlCol="0" anchor="b"/>
-          <a:lstStyle>
-            <a:lvl1pPr algn="l">
-              <a:defRPr sz="1200"/>
-            </a:lvl1pPr>
-          </a:lstStyle>
-          <a:p>
-            <a:endParaRPr lang="en-US"/>
-          </a:p>
-        </p:txBody>
-      </p:sp>
-      <p:sp>
-        <p:nvSpPr>
-          <p:cNvPr id="7" name="Slide Number Placeholder 6"/>
-          <p:cNvSpPr>
-            <a:spLocks noGrp="1"/>
-          </p:cNvSpPr>
-          <p:nvPr>
-            <p:ph type="sldNum" sz="quarter" idx="5"/>
-          </p:nvPr>
-        </p:nvSpPr>
-        <p:spPr>
-          <a:xfrm>
-            <a:off x="3884613" y="8685213"/>
-            <a:ext cx="2971800" cy="458787"/>
-          </a:xfrm>
-          <a:prstGeom prst="rect">
-            <a:avLst/>
-          </a:prstGeom>
-        </p:spPr>
-        <p:txBody>
-          <a:bodyPr vert="horz" lIns="91440" tIns="45720" rIns="91440" bIns="45720" rtlCol="0" anchor="b"/>
-          <a:lstStyle>
-            <a:lvl1pPr algn="r">
-              <a:defRPr sz="1200"/>
-            </a:lvl1pPr>
-          </a:lstStyle>
-          <a:p>
-            <a:fld id="{CE5E9CC1-C706-0F49-92D6-E571CC5EEA8F}" type="slidenum">
-              <a:rPr lang="en-US"/>
-              <a:t>‹#›</a:t>
-            </a:fld>
-            <a:endParaRPr lang="en-US"/>
-          </a:p>
-        </p:txBody>
-      </p:sp>
     </p:spTree>
     <p:extLst>
       <p:ext uri="{BB962C8B-B14F-4D97-AF65-F5344CB8AC3E}">
-        <p14:creationId xmlns:p14="http://schemas.microsoft.com/office/powerpoint/2010/main" val="1024086991"/>
+        <p14:creationId xmlns:p14="http://schemas.microsoft.com/office/powerpoint/2010/main" val="1584115759"/>
       </p:ext>
     </p:extLst>
   </p:cSld>
@@ -516,7 +297,6 @@
               <a:rPr lang="en-US" dirty="0"/>
               <a:t>Open with the one-liner: KaziOS is an operating system for African businesses — sales, stock, customers, books and payments in one connected system. I'm Mathew Kioko, founder and developer.</a:t>
             </a:r>
-            <a:endParaRPr lang="en-US" dirty="0"/>
           </a:p>
         </p:txBody>
       </p:sp>
@@ -604,7 +384,6 @@
               <a:rPr lang="en-US" dirty="0"/>
               <a:t>Signal engineering maturity: monorepo with shared packages, strict typing end-to-end, automated tests and gates, and payment-grade security posture.</a:t>
             </a:r>
-            <a:endParaRPr lang="en-US" dirty="0"/>
           </a:p>
         </p:txBody>
       </p:sp>
@@ -692,7 +471,6 @@
               <a:rPr lang="en-US" dirty="0"/>
               <a:t>The roadmap is the README checklist made visible: everything checked is live, everything unchecked is sequenced. Judges can verify by opening the public repo.</a:t>
             </a:r>
-            <a:endParaRPr lang="en-US" dirty="0"/>
           </a:p>
         </p:txBody>
       </p:sp>
@@ -780,7 +558,6 @@
               <a:rPr lang="en-US" dirty="0"/>
               <a:t>Close the argument: local-first product decisions, a connected data model, verifiable engineering, and a founder who ships. Then move to the thank-you slide.</a:t>
             </a:r>
-            <a:endParaRPr lang="en-US" dirty="0"/>
           </a:p>
         </p:txBody>
       </p:sp>
@@ -868,7 +645,6 @@
               <a:rPr lang="en-US" dirty="0"/>
               <a:t>Thank the jury, then invite a live demo — the POS flow and the M-PESA checkout both work end-to-end in the sandbox.</a:t>
             </a:r>
-            <a:endParaRPr lang="en-US" dirty="0"/>
           </a:p>
         </p:txBody>
       </p:sp>
@@ -956,7 +732,6 @@
               <a:rPr lang="en-US" dirty="0"/>
               <a:t>Most SMEs stitch together separate apps for each job. None of them talk to each other, so every sale creates reconciliation work and the numbers never agree.</a:t>
             </a:r>
-            <a:endParaRPr lang="en-US" dirty="0"/>
           </a:p>
         </p:txBody>
       </p:sp>
@@ -1044,7 +819,6 @@
               <a:rPr lang="en-US" dirty="0"/>
               <a:t>This is the wedge: global ERPs assume card payments, one HQ and always-on internet. KaziOS starts from African market realities.</a:t>
             </a:r>
-            <a:endParaRPr lang="en-US" dirty="0"/>
           </a:p>
         </p:txBody>
       </p:sp>
@@ -1132,7 +906,6 @@
               <a:rPr lang="en-US" dirty="0"/>
               <a:t>This is the core architectural idea, straight from the README: one sale fans out to six systems. No re-keying, no drift, no reconciliation tax.</a:t>
             </a:r>
-            <a:endParaRPr lang="en-US" dirty="0"/>
           </a:p>
         </p:txBody>
       </p:sp>
@@ -1220,7 +993,6 @@
               <a:rPr lang="en-US" dirty="0"/>
               <a:t>Walk one row only — juries skim. Point out that selling, stock, customers, purchasing, invoicing and payments are one data model, not eight apps glued together.</a:t>
             </a:r>
-            <a:endParaRPr lang="en-US" dirty="0"/>
           </a:p>
         </p:txBody>
       </p:sp>
@@ -1308,7 +1080,6 @@
               <a:rPr lang="en-US" dirty="0"/>
               <a:t>Two rails, one engine. The M-PESA side is the story: Daraja STK Push, server-side re-query as the only source of truth, idempotency and amount checks — payments engineering, not a button. The screenshot is the live billing portal with the Card/M-PESA rail toggle. Full trust list also covers: free plan and paid plans, monthly or annual, run on one engine; the billing portal issues invoices, receipts and plan changes.</a:t>
             </a:r>
-            <a:endParaRPr lang="en-US" dirty="0"/>
           </a:p>
         </p:txBody>
       </p:sp>
@@ -1396,7 +1167,6 @@
               <a:rPr lang="en-US" dirty="0"/>
               <a:t>No invented pricing numbers — the plan table is server-configurable per market. The point: free tier for adoption, paid tiers for capacity, local rails for conversion.</a:t>
             </a:r>
-            <a:endParaRPr lang="en-US" dirty="0"/>
           </a:p>
         </p:txBody>
       </p:sp>
@@ -1484,7 +1254,6 @@
               <a:rPr lang="en-US" dirty="0"/>
               <a:t>Kenya-first is deliberate: M-PESA rails, KRA eTIMS compliance path, English/Swahili market. Personas show we design for the people who touch the product daily.</a:t>
             </a:r>
-            <a:endParaRPr lang="en-US" dirty="0"/>
           </a:p>
         </p:txBody>
       </p:sp>
@@ -1572,7 +1341,6 @@
               <a:rPr lang="en-US" dirty="0"/>
               <a:t>Honest status builds trust with a jury: the foundation and both payment rails are live and tested; the deep workflows are sequenced next. No vaporware claims.</a:t>
             </a:r>
-            <a:endParaRPr lang="en-US" dirty="0"/>
           </a:p>
         </p:txBody>
       </p:sp>
@@ -1645,6 +1413,11 @@
 <file path=ppt/slideMasters/slideMaster1.xml><?xml version="1.0" encoding="utf-8"?>
 <p:sldMaster xmlns:a="http://schemas.openxmlformats.org/drawingml/2006/main" xmlns:r="http://schemas.openxmlformats.org/officeDocument/2006/relationships" xmlns:p="http://schemas.openxmlformats.org/presentationml/2006/main">
   <p:cSld>
+    <p:bg>
+      <p:bgRef idx="1001">
+        <a:schemeClr val="bg1"/>
+      </p:bgRef>
+    </p:bg>
     <p:spTree>
       <p:nvGrpSpPr>
         <p:cNvPr id="1" name=""/>
@@ -1927,6 +1700,7 @@
         <a:solidFill>
           <a:srgbClr val="081B36"/>
         </a:solidFill>
+        <a:effectLst/>
       </p:bgPr>
     </p:bg>
     <p:spTree>
@@ -1945,14 +1719,14 @@
       </p:grpSpPr>
       <p:pic>
         <p:nvPicPr>
-          <p:cNvPr id="2" name="Image 0" descr="C:/Users/ZBOOK/AppData/Local/Temp/kazi-deck/assets/logo-crop.png">    </p:cNvPr>
+          <p:cNvPr id="2" name="Image 0" descr="C:/Users/ZBOOK/AppData/Local/Temp/kazi-deck/assets/logo-crop.png"/>
           <p:cNvPicPr>
             <a:picLocks noChangeAspect="1"/>
           </p:cNvPicPr>
           <p:nvPr/>
         </p:nvPicPr>
         <p:blipFill>
-          <a:blip r:embed="rId1"/>
+          <a:blip r:embed="rId3"/>
           <a:stretch>
             <a:fillRect/>
           </a:stretch>
@@ -1988,7 +1762,7 @@
           <a:bodyPr wrap="square" rtlCol="0" anchor="ctr"/>
           <a:lstStyle/>
           <a:p>
-            <a:pPr algn="ctr" indent="0" marL="0">
+            <a:pPr marL="0" indent="0" algn="ctr">
               <a:buNone/>
             </a:pPr>
             <a:r>
@@ -2049,7 +1823,7 @@
           <a:bodyPr wrap="square" rtlCol="0" anchor="ctr"/>
           <a:lstStyle/>
           <a:p>
-            <a:pPr algn="ctr" indent="0" marL="0">
+            <a:pPr marL="0" indent="0" algn="ctr">
               <a:buNone/>
             </a:pPr>
             <a:r>
@@ -2088,7 +1862,7 @@
           <a:bodyPr wrap="square" rtlCol="0" anchor="ctr"/>
           <a:lstStyle/>
           <a:p>
-            <a:pPr algn="ctr" indent="0" marL="0">
+            <a:pPr marL="0" indent="0" algn="ctr">
               <a:buNone/>
             </a:pPr>
             <a:r>
@@ -2127,11 +1901,11 @@
           <a:bodyPr wrap="square" rtlCol="0" anchor="ctr"/>
           <a:lstStyle/>
           <a:p>
-            <a:pPr algn="ctr" indent="0" marL="0">
-              <a:buNone/>
-            </a:pPr>
-            <a:r>
-              <a:rPr lang="en-US" sz="1200" b="1" spc="300" kern="0" dirty="0">
+            <a:pPr marL="0" indent="0" algn="ctr">
+              <a:buNone/>
+            </a:pPr>
+            <a:r>
+              <a:rPr lang="en-US" sz="1200" b="1" kern="0" spc="300" dirty="0">
                 <a:solidFill>
                   <a:srgbClr val="8FA0BC"/>
                 </a:solidFill>
@@ -2161,6 +1935,7 @@
         <a:solidFill>
           <a:srgbClr val="07152D"/>
         </a:solidFill>
+        <a:effectLst/>
       </p:bgPr>
     </p:bg>
     <p:spTree>
@@ -2198,11 +1973,11 @@
           <a:bodyPr wrap="square" rtlCol="0" anchor="ctr"/>
           <a:lstStyle/>
           <a:p>
-            <a:pPr indent="0" marL="0">
-              <a:buNone/>
-            </a:pPr>
-            <a:r>
-              <a:rPr lang="en-US" sz="1100" b="1" spc="200" kern="0" dirty="0">
+            <a:pPr marL="0" indent="0">
+              <a:buNone/>
+            </a:pPr>
+            <a:r>
+              <a:rPr lang="en-US" sz="1100" b="1" kern="0" spc="200" dirty="0">
                 <a:solidFill>
                   <a:srgbClr val="F5A314"/>
                 </a:solidFill>
@@ -2237,7 +2012,7 @@
           <a:bodyPr wrap="square" rtlCol="0" anchor="ctr"/>
           <a:lstStyle/>
           <a:p>
-            <a:pPr indent="0" marL="0">
+            <a:pPr marL="0" indent="0">
               <a:buNone/>
             </a:pPr>
             <a:r>
@@ -2345,11 +2120,11 @@
           <a:bodyPr wrap="square" rtlCol="0" anchor="ctr"/>
           <a:lstStyle/>
           <a:p>
-            <a:pPr indent="0" marL="0">
-              <a:buNone/>
-            </a:pPr>
-            <a:r>
-              <a:rPr lang="en-US" sz="1600" b="1" spc="100" kern="0" dirty="0">
+            <a:pPr marL="0" indent="0">
+              <a:buNone/>
+            </a:pPr>
+            <a:r>
+              <a:rPr lang="en-US" sz="1600" b="1" kern="0" spc="100" dirty="0">
                 <a:solidFill>
                   <a:srgbClr val="F5F0E6"/>
                 </a:solidFill>
@@ -2558,11 +2333,11 @@
           <a:bodyPr wrap="square" rtlCol="0" anchor="ctr"/>
           <a:lstStyle/>
           <a:p>
-            <a:pPr indent="0" marL="0">
-              <a:buNone/>
-            </a:pPr>
-            <a:r>
-              <a:rPr lang="en-US" sz="1600" b="1" spc="100" kern="0" dirty="0">
+            <a:pPr marL="0" indent="0">
+              <a:buNone/>
+            </a:pPr>
+            <a:r>
+              <a:rPr lang="en-US" sz="1600" b="1" kern="0" spc="100" dirty="0">
                 <a:solidFill>
                   <a:srgbClr val="F5F0E6"/>
                 </a:solidFill>
@@ -2771,11 +2546,11 @@
           <a:bodyPr wrap="square" rtlCol="0" anchor="ctr"/>
           <a:lstStyle/>
           <a:p>
-            <a:pPr indent="0" marL="0">
-              <a:buNone/>
-            </a:pPr>
-            <a:r>
-              <a:rPr lang="en-US" sz="1600" b="1" spc="100" kern="0" dirty="0">
+            <a:pPr marL="0" indent="0">
+              <a:buNone/>
+            </a:pPr>
+            <a:r>
+              <a:rPr lang="en-US" sz="1600" b="1" kern="0" spc="100" dirty="0">
                 <a:solidFill>
                   <a:srgbClr val="F5F0E6"/>
                 </a:solidFill>
@@ -2964,7 +2739,7 @@
           <a:bodyPr wrap="square" rtlCol="0" anchor="ctr"/>
           <a:lstStyle/>
           <a:p>
-            <a:pPr algn="ctr" indent="0" marL="0">
+            <a:pPr marL="0" indent="0" algn="ctr">
               <a:buNone/>
             </a:pPr>
             <a:r>
@@ -2978,9 +2753,6 @@
               </a:rPr>
               <a:t>Quality gates: </a:t>
             </a:r>
-            <a:pPr algn="ctr" indent="0" marL="0">
-              <a:buNone/>
-            </a:pPr>
             <a:r>
               <a:rPr lang="en-US" sz="1300" dirty="0">
                 <a:solidFill>
@@ -2992,9 +2764,6 @@
               </a:rPr>
               <a:t>typecheck · lint · 190+ unit tests · integration suite      </a:t>
             </a:r>
-            <a:pPr algn="ctr" indent="0" marL="0">
-              <a:buNone/>
-            </a:pPr>
             <a:r>
               <a:rPr lang="en-US" sz="1300" b="1" dirty="0">
                 <a:solidFill>
@@ -3006,9 +2775,6 @@
               </a:rPr>
               <a:t>Security: </a:t>
             </a:r>
-            <a:pPr algn="ctr" indent="0" marL="0">
-              <a:buNone/>
-            </a:pPr>
             <a:r>
               <a:rPr lang="en-US" sz="1300" dirty="0">
                 <a:solidFill>
@@ -3065,7 +2831,7 @@
           <a:bodyPr wrap="square" rtlCol="0" anchor="ctr"/>
           <a:lstStyle/>
           <a:p>
-            <a:pPr algn="l" indent="0" marL="0">
+            <a:pPr marL="0" indent="0" algn="l">
               <a:buNone/>
             </a:pPr>
             <a:r>
@@ -3104,7 +2870,7 @@
           <a:bodyPr wrap="square" rtlCol="0" anchor="ctr"/>
           <a:lstStyle/>
           <a:p>
-            <a:pPr algn="r" indent="0" marL="0">
+            <a:pPr marL="0" indent="0" algn="r">
               <a:buNone/>
             </a:pPr>
             <a:r>
@@ -3138,6 +2904,7 @@
         <a:solidFill>
           <a:srgbClr val="07152D"/>
         </a:solidFill>
+        <a:effectLst/>
       </p:bgPr>
     </p:bg>
     <p:spTree>
@@ -3175,11 +2942,11 @@
           <a:bodyPr wrap="square" rtlCol="0" anchor="ctr"/>
           <a:lstStyle/>
           <a:p>
-            <a:pPr indent="0" marL="0">
-              <a:buNone/>
-            </a:pPr>
-            <a:r>
-              <a:rPr lang="en-US" sz="1100" b="1" spc="200" kern="0" dirty="0">
+            <a:pPr marL="0" indent="0">
+              <a:buNone/>
+            </a:pPr>
+            <a:r>
+              <a:rPr lang="en-US" sz="1100" b="1" kern="0" spc="200" dirty="0">
                 <a:solidFill>
                   <a:srgbClr val="F5A314"/>
                 </a:solidFill>
@@ -3214,7 +2981,7 @@
           <a:bodyPr wrap="square" rtlCol="0" anchor="ctr"/>
           <a:lstStyle/>
           <a:p>
-            <a:pPr indent="0" marL="0">
+            <a:pPr marL="0" indent="0">
               <a:buNone/>
             </a:pPr>
             <a:r>
@@ -3324,11 +3091,11 @@
           <a:bodyPr wrap="square" rtlCol="0" anchor="ctr"/>
           <a:lstStyle/>
           <a:p>
-            <a:pPr algn="ctr" indent="0" marL="0">
-              <a:buNone/>
-            </a:pPr>
-            <a:r>
-              <a:rPr lang="en-US" sz="1800" b="1" spc="200" kern="0" dirty="0">
+            <a:pPr marL="0" indent="0" algn="ctr">
+              <a:buNone/>
+            </a:pPr>
+            <a:r>
+              <a:rPr lang="en-US" sz="1800" b="1" kern="0" spc="200" dirty="0">
                 <a:solidFill>
                   <a:srgbClr val="081B36"/>
                 </a:solidFill>
@@ -3363,7 +3130,7 @@
           <a:bodyPr wrap="square" rtlCol="0" anchor="ctr"/>
           <a:lstStyle/>
           <a:p>
-            <a:pPr indent="0" marL="0">
+            <a:pPr marL="0" indent="0">
               <a:buNone/>
             </a:pPr>
             <a:r>
@@ -3508,7 +3275,7 @@
           <a:bodyPr wrap="square" rtlCol="0" anchor="ctr"/>
           <a:lstStyle/>
           <a:p>
-            <a:pPr algn="ctr" indent="0" marL="0">
+            <a:pPr marL="0" indent="0" algn="ctr">
               <a:buNone/>
             </a:pPr>
             <a:r>
@@ -3596,11 +3363,11 @@
           <a:bodyPr wrap="square" rtlCol="0" anchor="ctr"/>
           <a:lstStyle/>
           <a:p>
-            <a:pPr algn="ctr" indent="0" marL="0">
-              <a:buNone/>
-            </a:pPr>
-            <a:r>
-              <a:rPr lang="en-US" sz="1800" b="1" spc="200" kern="0" dirty="0">
+            <a:pPr marL="0" indent="0" algn="ctr">
+              <a:buNone/>
+            </a:pPr>
+            <a:r>
+              <a:rPr lang="en-US" sz="1800" b="1" kern="0" spc="200" dirty="0">
                 <a:solidFill>
                   <a:srgbClr val="081B36"/>
                 </a:solidFill>
@@ -3635,7 +3402,7 @@
           <a:bodyPr wrap="square" rtlCol="0" anchor="ctr"/>
           <a:lstStyle/>
           <a:p>
-            <a:pPr indent="0" marL="0">
+            <a:pPr marL="0" indent="0">
               <a:buNone/>
             </a:pPr>
             <a:r>
@@ -3780,7 +3547,7 @@
           <a:bodyPr wrap="square" rtlCol="0" anchor="ctr"/>
           <a:lstStyle/>
           <a:p>
-            <a:pPr algn="ctr" indent="0" marL="0">
+            <a:pPr marL="0" indent="0" algn="ctr">
               <a:buNone/>
             </a:pPr>
             <a:r>
@@ -3868,11 +3635,11 @@
           <a:bodyPr wrap="square" rtlCol="0" anchor="ctr"/>
           <a:lstStyle/>
           <a:p>
-            <a:pPr algn="ctr" indent="0" marL="0">
-              <a:buNone/>
-            </a:pPr>
-            <a:r>
-              <a:rPr lang="en-US" sz="1800" b="1" spc="200" kern="0" dirty="0">
+            <a:pPr marL="0" indent="0" algn="ctr">
+              <a:buNone/>
+            </a:pPr>
+            <a:r>
+              <a:rPr lang="en-US" sz="1800" b="1" kern="0" spc="200" dirty="0">
                 <a:solidFill>
                   <a:srgbClr val="081B36"/>
                 </a:solidFill>
@@ -3907,7 +3674,7 @@
           <a:bodyPr wrap="square" rtlCol="0" anchor="ctr"/>
           <a:lstStyle/>
           <a:p>
-            <a:pPr indent="0" marL="0">
+            <a:pPr marL="0" indent="0">
               <a:buNone/>
             </a:pPr>
             <a:r>
@@ -4072,7 +3839,7 @@
           <a:bodyPr wrap="square" rtlCol="0" anchor="ctr"/>
           <a:lstStyle/>
           <a:p>
-            <a:pPr algn="l" indent="0" marL="0">
+            <a:pPr marL="0" indent="0" algn="l">
               <a:buNone/>
             </a:pPr>
             <a:r>
@@ -4111,7 +3878,7 @@
           <a:bodyPr wrap="square" rtlCol="0" anchor="ctr"/>
           <a:lstStyle/>
           <a:p>
-            <a:pPr algn="r" indent="0" marL="0">
+            <a:pPr marL="0" indent="0" algn="r">
               <a:buNone/>
             </a:pPr>
             <a:r>
@@ -4145,6 +3912,7 @@
         <a:solidFill>
           <a:srgbClr val="07152D"/>
         </a:solidFill>
+        <a:effectLst/>
       </p:bgPr>
     </p:bg>
     <p:spTree>
@@ -4182,11 +3950,11 @@
           <a:bodyPr wrap="square" rtlCol="0" anchor="ctr"/>
           <a:lstStyle/>
           <a:p>
-            <a:pPr indent="0" marL="0">
-              <a:buNone/>
-            </a:pPr>
-            <a:r>
-              <a:rPr lang="en-US" sz="1100" b="1" spc="200" kern="0" dirty="0">
+            <a:pPr marL="0" indent="0">
+              <a:buNone/>
+            </a:pPr>
+            <a:r>
+              <a:rPr lang="en-US" sz="1100" b="1" kern="0" spc="200" dirty="0">
                 <a:solidFill>
                   <a:srgbClr val="F5A314"/>
                 </a:solidFill>
@@ -4221,7 +3989,7 @@
           <a:bodyPr wrap="square" rtlCol="0" anchor="ctr"/>
           <a:lstStyle/>
           <a:p>
-            <a:pPr indent="0" marL="0">
+            <a:pPr marL="0" indent="0">
               <a:buNone/>
             </a:pPr>
             <a:r>
@@ -4329,7 +4097,7 @@
           <a:bodyPr wrap="square" rtlCol="0" anchor="ctr"/>
           <a:lstStyle/>
           <a:p>
-            <a:pPr indent="0" marL="0">
+            <a:pPr marL="0" indent="0">
               <a:buNone/>
             </a:pPr>
             <a:r>
@@ -4368,7 +4136,7 @@
           <a:bodyPr wrap="square" rtlCol="0" anchor="t"/>
           <a:lstStyle/>
           <a:p>
-            <a:pPr indent="0" marL="0">
+            <a:pPr marL="0" indent="0">
               <a:buNone/>
             </a:pPr>
             <a:r>
@@ -4454,7 +4222,7 @@
           <a:bodyPr wrap="square" rtlCol="0" anchor="ctr"/>
           <a:lstStyle/>
           <a:p>
-            <a:pPr indent="0" marL="0">
+            <a:pPr marL="0" indent="0">
               <a:buNone/>
             </a:pPr>
             <a:r>
@@ -4493,7 +4261,7 @@
           <a:bodyPr wrap="square" rtlCol="0" anchor="t"/>
           <a:lstStyle/>
           <a:p>
-            <a:pPr indent="0" marL="0">
+            <a:pPr marL="0" indent="0">
               <a:buNone/>
             </a:pPr>
             <a:r>
@@ -4579,7 +4347,7 @@
           <a:bodyPr wrap="square" rtlCol="0" anchor="ctr"/>
           <a:lstStyle/>
           <a:p>
-            <a:pPr indent="0" marL="0">
+            <a:pPr marL="0" indent="0">
               <a:buNone/>
             </a:pPr>
             <a:r>
@@ -4618,7 +4386,7 @@
           <a:bodyPr wrap="square" rtlCol="0" anchor="t"/>
           <a:lstStyle/>
           <a:p>
-            <a:pPr indent="0" marL="0">
+            <a:pPr marL="0" indent="0">
               <a:buNone/>
             </a:pPr>
             <a:r>
@@ -4704,7 +4472,7 @@
           <a:bodyPr wrap="square" rtlCol="0" anchor="ctr"/>
           <a:lstStyle/>
           <a:p>
-            <a:pPr indent="0" marL="0">
+            <a:pPr marL="0" indent="0">
               <a:buNone/>
             </a:pPr>
             <a:r>
@@ -4743,7 +4511,7 @@
           <a:bodyPr wrap="square" rtlCol="0" anchor="t"/>
           <a:lstStyle/>
           <a:p>
-            <a:pPr indent="0" marL="0">
+            <a:pPr marL="0" indent="0">
               <a:buNone/>
             </a:pPr>
             <a:r>
@@ -4782,7 +4550,7 @@
           <a:bodyPr wrap="square" rtlCol="0" anchor="ctr"/>
           <a:lstStyle/>
           <a:p>
-            <a:pPr algn="ctr" indent="0" marL="0">
+            <a:pPr marL="0" indent="0" algn="ctr">
               <a:buNone/>
             </a:pPr>
             <a:r>
@@ -4841,7 +4609,7 @@
           <a:bodyPr wrap="square" rtlCol="0" anchor="ctr"/>
           <a:lstStyle/>
           <a:p>
-            <a:pPr algn="l" indent="0" marL="0">
+            <a:pPr marL="0" indent="0" algn="l">
               <a:buNone/>
             </a:pPr>
             <a:r>
@@ -4880,7 +4648,7 @@
           <a:bodyPr wrap="square" rtlCol="0" anchor="ctr"/>
           <a:lstStyle/>
           <a:p>
-            <a:pPr algn="r" indent="0" marL="0">
+            <a:pPr marL="0" indent="0" algn="r">
               <a:buNone/>
             </a:pPr>
             <a:r>
@@ -4914,6 +4682,7 @@
         <a:solidFill>
           <a:srgbClr val="081B36"/>
         </a:solidFill>
+        <a:effectLst/>
       </p:bgPr>
     </p:bg>
     <p:spTree>
@@ -4932,14 +4701,14 @@
       </p:grpSpPr>
       <p:pic>
         <p:nvPicPr>
-          <p:cNvPr id="2" name="Image 0" descr="C:/Users/ZBOOK/AppData/Local/Temp/kazi-deck/assets/icon-tile.png">    </p:cNvPr>
+          <p:cNvPr id="2" name="Image 0" descr="C:/Users/ZBOOK/AppData/Local/Temp/kazi-deck/assets/icon-tile.png"/>
           <p:cNvPicPr>
             <a:picLocks noChangeAspect="1"/>
           </p:cNvPicPr>
           <p:nvPr/>
         </p:nvPicPr>
         <p:blipFill>
-          <a:blip r:embed="rId1"/>
+          <a:blip r:embed="rId3"/>
           <a:stretch>
             <a:fillRect/>
           </a:stretch>
@@ -4975,7 +4744,7 @@
           <a:bodyPr wrap="square" rtlCol="0" anchor="ctr"/>
           <a:lstStyle/>
           <a:p>
-            <a:pPr indent="0" marL="0">
+            <a:pPr marL="0" indent="0">
               <a:buNone/>
             </a:pPr>
             <a:r>
@@ -5036,7 +4805,7 @@
           <a:bodyPr wrap="square" rtlCol="0" anchor="t"/>
           <a:lstStyle/>
           <a:p>
-            <a:pPr indent="0" marL="0">
+            <a:pPr marL="0" indent="0">
               <a:buNone/>
             </a:pPr>
             <a:r>
@@ -5075,7 +4844,7 @@
           <a:bodyPr wrap="square" rtlCol="0" anchor="t"/>
           <a:lstStyle/>
           <a:p>
-            <a:pPr indent="0" marL="0">
+            <a:pPr marL="0" indent="0">
               <a:buNone/>
             </a:pPr>
             <a:r>
@@ -5092,11 +4861,11 @@
             <a:endParaRPr lang="en-US" sz="1450" dirty="0"/>
           </a:p>
           <a:p>
-            <a:pPr indent="0" marL="0">
-              <a:buNone/>
-            </a:pPr>
-            <a:r>
-              <a:rPr lang="en-US" sz="1450" b="1" dirty="0">
+            <a:pPr marL="0" indent="0">
+              <a:buNone/>
+            </a:pPr>
+            <a:r>
+              <a:rPr lang="en-US" sz="1450" b="1" dirty="0" smtClean="0">
                 <a:solidFill>
                   <a:srgbClr val="F5A314"/>
                 </a:solidFill>
@@ -5104,24 +4873,18 @@
                 <a:ea typeface="Calibri" pitchFamily="34" charset="-122"/>
                 <a:cs typeface="Calibri" pitchFamily="34" charset="-120"/>
               </a:rPr>
-              <a:t>github.com/MathewTech254/KaziOs</a:t>
-            </a:r>
-            <a:endParaRPr lang="en-US" sz="1450" dirty="0"/>
-          </a:p>
-          <a:p>
-            <a:pPr indent="0" marL="0">
-              <a:buNone/>
-            </a:pPr>
-            <a:r>
-              <a:rPr lang="en-US" sz="1450" b="1" dirty="0">
-                <a:solidFill>
-                  <a:srgbClr val="8FA0BC"/>
-                </a:solidFill>
-                <a:latin typeface="Calibri" pitchFamily="34" charset="0"/>
-                <a:ea typeface="Calibri" pitchFamily="34" charset="-122"/>
-                <a:cs typeface="Calibri" pitchFamily="34" charset="-120"/>
-              </a:rPr>
-              <a:t>Questions &amp; demo welcome</a:t>
+              <a:t>github.com/MathewTech254/</a:t>
+            </a:r>
+            <a:r>
+              <a:rPr lang="en-US" sz="1450" b="1" dirty="0" err="1" smtClean="0">
+                <a:solidFill>
+                  <a:srgbClr val="F5A314"/>
+                </a:solidFill>
+                <a:latin typeface="Calibri" pitchFamily="34" charset="0"/>
+                <a:ea typeface="Calibri" pitchFamily="34" charset="-122"/>
+                <a:cs typeface="Calibri" pitchFamily="34" charset="-120"/>
+              </a:rPr>
+              <a:t>KaziOs</a:t>
             </a:r>
             <a:endParaRPr lang="en-US" sz="1450" dirty="0"/>
           </a:p>
@@ -5143,6 +4906,7 @@
         <a:solidFill>
           <a:srgbClr val="07152D"/>
         </a:solidFill>
+        <a:effectLst/>
       </p:bgPr>
     </p:bg>
     <p:spTree>
@@ -5180,11 +4944,11 @@
           <a:bodyPr wrap="square" rtlCol="0" anchor="ctr"/>
           <a:lstStyle/>
           <a:p>
-            <a:pPr indent="0" marL="0">
-              <a:buNone/>
-            </a:pPr>
-            <a:r>
-              <a:rPr lang="en-US" sz="1100" b="1" spc="200" kern="0" dirty="0">
+            <a:pPr marL="0" indent="0">
+              <a:buNone/>
+            </a:pPr>
+            <a:r>
+              <a:rPr lang="en-US" sz="1100" b="1" kern="0" spc="200" dirty="0">
                 <a:solidFill>
                   <a:srgbClr val="F5A314"/>
                 </a:solidFill>
@@ -5219,7 +4983,7 @@
           <a:bodyPr wrap="square" rtlCol="0" anchor="ctr"/>
           <a:lstStyle/>
           <a:p>
-            <a:pPr indent="0" marL="0">
+            <a:pPr marL="0" indent="0">
               <a:buNone/>
             </a:pPr>
             <a:r>
@@ -5307,7 +5071,7 @@
           <a:bodyPr wrap="square" rtlCol="0" anchor="ctr"/>
           <a:lstStyle/>
           <a:p>
-            <a:pPr algn="ctr" indent="0" marL="0">
+            <a:pPr marL="0" indent="0" algn="ctr">
               <a:buNone/>
             </a:pPr>
             <a:r>
@@ -5373,7 +5137,7 @@
           <a:bodyPr wrap="square" rtlCol="0" anchor="ctr"/>
           <a:lstStyle/>
           <a:p>
-            <a:pPr algn="ctr" indent="0" marL="0">
+            <a:pPr marL="0" indent="0" algn="ctr">
               <a:buNone/>
             </a:pPr>
             <a:r>
@@ -5439,7 +5203,7 @@
           <a:bodyPr wrap="square" rtlCol="0" anchor="ctr"/>
           <a:lstStyle/>
           <a:p>
-            <a:pPr algn="ctr" indent="0" marL="0">
+            <a:pPr marL="0" indent="0" algn="ctr">
               <a:buNone/>
             </a:pPr>
             <a:r>
@@ -5505,7 +5269,7 @@
           <a:bodyPr wrap="square" rtlCol="0" anchor="ctr"/>
           <a:lstStyle/>
           <a:p>
-            <a:pPr algn="ctr" indent="0" marL="0">
+            <a:pPr marL="0" indent="0" algn="ctr">
               <a:buNone/>
             </a:pPr>
             <a:r>
@@ -5571,7 +5335,7 @@
           <a:bodyPr wrap="square" rtlCol="0" anchor="ctr"/>
           <a:lstStyle/>
           <a:p>
-            <a:pPr algn="ctr" indent="0" marL="0">
+            <a:pPr marL="0" indent="0" algn="ctr">
               <a:buNone/>
             </a:pPr>
             <a:r>
@@ -5637,7 +5401,7 @@
           <a:bodyPr wrap="square" rtlCol="0" anchor="ctr"/>
           <a:lstStyle/>
           <a:p>
-            <a:pPr algn="ctr" indent="0" marL="0">
+            <a:pPr marL="0" indent="0" algn="ctr">
               <a:buNone/>
             </a:pPr>
             <a:r>
@@ -5703,7 +5467,7 @@
           <a:bodyPr wrap="square" rtlCol="0" anchor="ctr"/>
           <a:lstStyle/>
           <a:p>
-            <a:pPr algn="ctr" indent="0" marL="0">
+            <a:pPr marL="0" indent="0" algn="ctr">
               <a:buNone/>
             </a:pPr>
             <a:r>
@@ -5769,7 +5533,7 @@
           <a:bodyPr wrap="square" rtlCol="0" anchor="ctr"/>
           <a:lstStyle/>
           <a:p>
-            <a:pPr algn="ctr" indent="0" marL="0">
+            <a:pPr marL="0" indent="0" algn="ctr">
               <a:buNone/>
             </a:pPr>
             <a:r>
@@ -5835,7 +5599,7 @@
           <a:bodyPr wrap="square" rtlCol="0" anchor="ctr"/>
           <a:lstStyle/>
           <a:p>
-            <a:pPr algn="ctr" indent="0" marL="0">
+            <a:pPr marL="0" indent="0" algn="ctr">
               <a:buNone/>
             </a:pPr>
             <a:r>
@@ -5901,7 +5665,7 @@
           <a:bodyPr wrap="square" rtlCol="0" anchor="ctr"/>
           <a:lstStyle/>
           <a:p>
-            <a:pPr algn="ctr" indent="0" marL="0">
+            <a:pPr marL="0" indent="0" algn="ctr">
               <a:buNone/>
             </a:pPr>
             <a:r>
@@ -5987,7 +5751,7 @@
           <a:bodyPr wrap="square" rtlCol="0" anchor="ctr"/>
           <a:lstStyle/>
           <a:p>
-            <a:pPr indent="0" marL="0">
+            <a:pPr marL="0" indent="0">
               <a:buNone/>
             </a:pPr>
             <a:r>
@@ -6026,7 +5790,7 @@
           <a:bodyPr wrap="square" rtlCol="0" anchor="t"/>
           <a:lstStyle/>
           <a:p>
-            <a:pPr indent="0" marL="0">
+            <a:pPr marL="0" indent="0">
               <a:buNone/>
             </a:pPr>
             <a:r>
@@ -6112,7 +5876,7 @@
           <a:bodyPr wrap="square" rtlCol="0" anchor="ctr"/>
           <a:lstStyle/>
           <a:p>
-            <a:pPr indent="0" marL="0">
+            <a:pPr marL="0" indent="0">
               <a:buNone/>
             </a:pPr>
             <a:r>
@@ -6151,7 +5915,7 @@
           <a:bodyPr wrap="square" rtlCol="0" anchor="t"/>
           <a:lstStyle/>
           <a:p>
-            <a:pPr indent="0" marL="0">
+            <a:pPr marL="0" indent="0">
               <a:buNone/>
             </a:pPr>
             <a:r>
@@ -6237,7 +6001,7 @@
           <a:bodyPr wrap="square" rtlCol="0" anchor="ctr"/>
           <a:lstStyle/>
           <a:p>
-            <a:pPr indent="0" marL="0">
+            <a:pPr marL="0" indent="0">
               <a:buNone/>
             </a:pPr>
             <a:r>
@@ -6276,7 +6040,7 @@
           <a:bodyPr wrap="square" rtlCol="0" anchor="t"/>
           <a:lstStyle/>
           <a:p>
-            <a:pPr indent="0" marL="0">
+            <a:pPr marL="0" indent="0">
               <a:buNone/>
             </a:pPr>
             <a:r>
@@ -6362,7 +6126,7 @@
           <a:bodyPr wrap="square" rtlCol="0" anchor="ctr"/>
           <a:lstStyle/>
           <a:p>
-            <a:pPr indent="0" marL="0">
+            <a:pPr marL="0" indent="0">
               <a:buNone/>
             </a:pPr>
             <a:r>
@@ -6401,7 +6165,7 @@
           <a:bodyPr wrap="square" rtlCol="0" anchor="t"/>
           <a:lstStyle/>
           <a:p>
-            <a:pPr indent="0" marL="0">
+            <a:pPr marL="0" indent="0">
               <a:buNone/>
             </a:pPr>
             <a:r>
@@ -6460,7 +6224,7 @@
           <a:bodyPr wrap="square" rtlCol="0" anchor="ctr"/>
           <a:lstStyle/>
           <a:p>
-            <a:pPr algn="l" indent="0" marL="0">
+            <a:pPr marL="0" indent="0" algn="l">
               <a:buNone/>
             </a:pPr>
             <a:r>
@@ -6499,7 +6263,7 @@
           <a:bodyPr wrap="square" rtlCol="0" anchor="ctr"/>
           <a:lstStyle/>
           <a:p>
-            <a:pPr algn="r" indent="0" marL="0">
+            <a:pPr marL="0" indent="0" algn="r">
               <a:buNone/>
             </a:pPr>
             <a:r>
@@ -6533,6 +6297,7 @@
         <a:solidFill>
           <a:srgbClr val="07152D"/>
         </a:solidFill>
+        <a:effectLst/>
       </p:bgPr>
     </p:bg>
     <p:spTree>
@@ -6570,11 +6335,11 @@
           <a:bodyPr wrap="square" rtlCol="0" anchor="ctr"/>
           <a:lstStyle/>
           <a:p>
-            <a:pPr indent="0" marL="0">
-              <a:buNone/>
-            </a:pPr>
-            <a:r>
-              <a:rPr lang="en-US" sz="1100" b="1" spc="200" kern="0" dirty="0">
+            <a:pPr marL="0" indent="0">
+              <a:buNone/>
+            </a:pPr>
+            <a:r>
+              <a:rPr lang="en-US" sz="1100" b="1" kern="0" spc="200" dirty="0">
                 <a:solidFill>
                   <a:srgbClr val="F5A314"/>
                 </a:solidFill>
@@ -6609,7 +6374,7 @@
           <a:bodyPr wrap="square" rtlCol="0" anchor="ctr"/>
           <a:lstStyle/>
           <a:p>
-            <a:pPr indent="0" marL="0">
+            <a:pPr marL="0" indent="0">
               <a:buNone/>
             </a:pPr>
             <a:r>
@@ -6717,7 +6482,7 @@
           <a:bodyPr wrap="square" rtlCol="0" anchor="ctr"/>
           <a:lstStyle/>
           <a:p>
-            <a:pPr indent="0" marL="0">
+            <a:pPr marL="0" indent="0">
               <a:buNone/>
             </a:pPr>
             <a:r>
@@ -6756,7 +6521,7 @@
           <a:bodyPr wrap="square" rtlCol="0" anchor="t"/>
           <a:lstStyle/>
           <a:p>
-            <a:pPr indent="0" marL="0">
+            <a:pPr marL="0" indent="0">
               <a:buNone/>
             </a:pPr>
             <a:r>
@@ -6842,7 +6607,7 @@
           <a:bodyPr wrap="square" rtlCol="0" anchor="ctr"/>
           <a:lstStyle/>
           <a:p>
-            <a:pPr indent="0" marL="0">
+            <a:pPr marL="0" indent="0">
               <a:buNone/>
             </a:pPr>
             <a:r>
@@ -6881,7 +6646,7 @@
           <a:bodyPr wrap="square" rtlCol="0" anchor="t"/>
           <a:lstStyle/>
           <a:p>
-            <a:pPr indent="0" marL="0">
+            <a:pPr marL="0" indent="0">
               <a:buNone/>
             </a:pPr>
             <a:r>
@@ -6967,7 +6732,7 @@
           <a:bodyPr wrap="square" rtlCol="0" anchor="ctr"/>
           <a:lstStyle/>
           <a:p>
-            <a:pPr indent="0" marL="0">
+            <a:pPr marL="0" indent="0">
               <a:buNone/>
             </a:pPr>
             <a:r>
@@ -7006,7 +6771,7 @@
           <a:bodyPr wrap="square" rtlCol="0" anchor="t"/>
           <a:lstStyle/>
           <a:p>
-            <a:pPr indent="0" marL="0">
+            <a:pPr marL="0" indent="0">
               <a:buNone/>
             </a:pPr>
             <a:r>
@@ -7092,7 +6857,7 @@
           <a:bodyPr wrap="square" rtlCol="0" anchor="ctr"/>
           <a:lstStyle/>
           <a:p>
-            <a:pPr indent="0" marL="0">
+            <a:pPr marL="0" indent="0">
               <a:buNone/>
             </a:pPr>
             <a:r>
@@ -7131,7 +6896,7 @@
           <a:bodyPr wrap="square" rtlCol="0" anchor="t"/>
           <a:lstStyle/>
           <a:p>
-            <a:pPr indent="0" marL="0">
+            <a:pPr marL="0" indent="0">
               <a:buNone/>
             </a:pPr>
             <a:r>
@@ -7190,7 +6955,7 @@
           <a:bodyPr wrap="square" rtlCol="0" anchor="ctr"/>
           <a:lstStyle/>
           <a:p>
-            <a:pPr algn="l" indent="0" marL="0">
+            <a:pPr marL="0" indent="0" algn="l">
               <a:buNone/>
             </a:pPr>
             <a:r>
@@ -7229,7 +6994,7 @@
           <a:bodyPr wrap="square" rtlCol="0" anchor="ctr"/>
           <a:lstStyle/>
           <a:p>
-            <a:pPr algn="r" indent="0" marL="0">
+            <a:pPr marL="0" indent="0" algn="r">
               <a:buNone/>
             </a:pPr>
             <a:r>
@@ -7263,6 +7028,7 @@
         <a:solidFill>
           <a:srgbClr val="07152D"/>
         </a:solidFill>
+        <a:effectLst/>
       </p:bgPr>
     </p:bg>
     <p:spTree>
@@ -7300,11 +7066,11 @@
           <a:bodyPr wrap="square" rtlCol="0" anchor="ctr"/>
           <a:lstStyle/>
           <a:p>
-            <a:pPr indent="0" marL="0">
-              <a:buNone/>
-            </a:pPr>
-            <a:r>
-              <a:rPr lang="en-US" sz="1100" b="1" spc="200" kern="0" dirty="0">
+            <a:pPr marL="0" indent="0">
+              <a:buNone/>
+            </a:pPr>
+            <a:r>
+              <a:rPr lang="en-US" sz="1100" b="1" kern="0" spc="200" dirty="0">
                 <a:solidFill>
                   <a:srgbClr val="F5A314"/>
                 </a:solidFill>
@@ -7339,7 +7105,7 @@
           <a:bodyPr wrap="square" rtlCol="0" anchor="ctr"/>
           <a:lstStyle/>
           <a:p>
-            <a:pPr indent="0" marL="0">
+            <a:pPr marL="0" indent="0">
               <a:buNone/>
             </a:pPr>
             <a:r>
@@ -7400,7 +7166,7 @@
           <a:bodyPr wrap="square" rtlCol="0" anchor="ctr"/>
           <a:lstStyle/>
           <a:p>
-            <a:pPr indent="0" marL="0">
+            <a:pPr marL="0" indent="0">
               <a:buNone/>
             </a:pPr>
             <a:r>
@@ -7599,7 +7365,7 @@
           <a:bodyPr wrap="square" rtlCol="0" anchor="ctr"/>
           <a:lstStyle/>
           <a:p>
-            <a:pPr algn="ctr" indent="0" marL="0">
+            <a:pPr marL="0" indent="0" algn="ctr">
               <a:buNone/>
             </a:pPr>
             <a:r>
@@ -7685,7 +7451,7 @@
           <a:bodyPr wrap="square" rtlCol="0" anchor="ctr"/>
           <a:lstStyle/>
           <a:p>
-            <a:pPr indent="0" marL="0">
+            <a:pPr marL="0" indent="0">
               <a:buNone/>
             </a:pPr>
             <a:r>
@@ -7771,7 +7537,7 @@
           <a:bodyPr wrap="square" rtlCol="0" anchor="ctr"/>
           <a:lstStyle/>
           <a:p>
-            <a:pPr indent="0" marL="0">
+            <a:pPr marL="0" indent="0">
               <a:buNone/>
             </a:pPr>
             <a:r>
@@ -7857,7 +7623,7 @@
           <a:bodyPr wrap="square" rtlCol="0" anchor="ctr"/>
           <a:lstStyle/>
           <a:p>
-            <a:pPr indent="0" marL="0">
+            <a:pPr marL="0" indent="0">
               <a:buNone/>
             </a:pPr>
             <a:r>
@@ -7943,7 +7709,7 @@
           <a:bodyPr wrap="square" rtlCol="0" anchor="ctr"/>
           <a:lstStyle/>
           <a:p>
-            <a:pPr indent="0" marL="0">
+            <a:pPr marL="0" indent="0">
               <a:buNone/>
             </a:pPr>
             <a:r>
@@ -8029,7 +7795,7 @@
           <a:bodyPr wrap="square" rtlCol="0" anchor="ctr"/>
           <a:lstStyle/>
           <a:p>
-            <a:pPr indent="0" marL="0">
+            <a:pPr marL="0" indent="0">
               <a:buNone/>
             </a:pPr>
             <a:r>
@@ -8115,7 +7881,7 @@
           <a:bodyPr wrap="square" rtlCol="0" anchor="ctr"/>
           <a:lstStyle/>
           <a:p>
-            <a:pPr indent="0" marL="0">
+            <a:pPr marL="0" indent="0">
               <a:buNone/>
             </a:pPr>
             <a:r>
@@ -8154,7 +7920,7 @@
           <a:bodyPr wrap="square" rtlCol="0" anchor="t"/>
           <a:lstStyle/>
           <a:p>
-            <a:pPr indent="0" marL="0">
+            <a:pPr marL="0" indent="0">
               <a:buNone/>
             </a:pPr>
             <a:r>
@@ -8193,7 +7959,7 @@
           <a:bodyPr wrap="square" rtlCol="0" anchor="t"/>
           <a:lstStyle/>
           <a:p>
-            <a:pPr indent="0" marL="0">
+            <a:pPr marL="0" indent="0">
               <a:buNone/>
             </a:pPr>
             <a:r>
@@ -8252,7 +8018,7 @@
           <a:bodyPr wrap="square" rtlCol="0" anchor="ctr"/>
           <a:lstStyle/>
           <a:p>
-            <a:pPr algn="l" indent="0" marL="0">
+            <a:pPr marL="0" indent="0" algn="l">
               <a:buNone/>
             </a:pPr>
             <a:r>
@@ -8291,7 +8057,7 @@
           <a:bodyPr wrap="square" rtlCol="0" anchor="ctr"/>
           <a:lstStyle/>
           <a:p>
-            <a:pPr algn="r" indent="0" marL="0">
+            <a:pPr marL="0" indent="0" algn="r">
               <a:buNone/>
             </a:pPr>
             <a:r>
@@ -8325,6 +8091,7 @@
         <a:solidFill>
           <a:srgbClr val="07152D"/>
         </a:solidFill>
+        <a:effectLst/>
       </p:bgPr>
     </p:bg>
     <p:spTree>
@@ -8362,11 +8129,11 @@
           <a:bodyPr wrap="square" rtlCol="0" anchor="ctr"/>
           <a:lstStyle/>
           <a:p>
-            <a:pPr indent="0" marL="0">
-              <a:buNone/>
-            </a:pPr>
-            <a:r>
-              <a:rPr lang="en-US" sz="1100" b="1" spc="200" kern="0" dirty="0">
+            <a:pPr marL="0" indent="0">
+              <a:buNone/>
+            </a:pPr>
+            <a:r>
+              <a:rPr lang="en-US" sz="1100" b="1" kern="0" spc="200" dirty="0">
                 <a:solidFill>
                   <a:srgbClr val="F5A314"/>
                 </a:solidFill>
@@ -8401,7 +8168,7 @@
           <a:bodyPr wrap="square" rtlCol="0" anchor="ctr"/>
           <a:lstStyle/>
           <a:p>
-            <a:pPr indent="0" marL="0">
+            <a:pPr marL="0" indent="0">
               <a:buNone/>
             </a:pPr>
             <a:r>
@@ -8462,7 +8229,7 @@
           <a:bodyPr wrap="square" rtlCol="0" anchor="ctr"/>
           <a:lstStyle/>
           <a:p>
-            <a:pPr indent="0" marL="0">
+            <a:pPr marL="0" indent="0">
               <a:buNone/>
             </a:pPr>
             <a:r>
@@ -8509,14 +8276,14 @@
       </p:sp>
       <p:pic>
         <p:nvPicPr>
-          <p:cNvPr id="7" name="Image 0" descr="C:/Users/ZBOOK/AppData/Local/Temp/kazi-deck/assets/shot-pos.png">    </p:cNvPr>
+          <p:cNvPr id="7" name="Image 0" descr="C:/Users/ZBOOK/AppData/Local/Temp/kazi-deck/assets/shot-pos.png"/>
           <p:cNvPicPr>
             <a:picLocks noChangeAspect="1"/>
           </p:cNvPicPr>
           <p:nvPr/>
         </p:nvPicPr>
         <p:blipFill>
-          <a:blip r:embed="rId1"/>
+          <a:blip r:embed="rId3"/>
           <a:stretch>
             <a:fillRect/>
           </a:stretch>
@@ -8552,7 +8319,7 @@
           <a:bodyPr wrap="square" rtlCol="0" anchor="ctr"/>
           <a:lstStyle/>
           <a:p>
-            <a:pPr indent="0" marL="0">
+            <a:pPr marL="0" indent="0">
               <a:buNone/>
             </a:pPr>
             <a:r>
@@ -8638,7 +8405,7 @@
           <a:bodyPr wrap="square" rtlCol="0" anchor="ctr"/>
           <a:lstStyle/>
           <a:p>
-            <a:pPr indent="0" marL="0">
+            <a:pPr marL="0" indent="0">
               <a:buNone/>
             </a:pPr>
             <a:r>
@@ -8677,7 +8444,7 @@
           <a:bodyPr wrap="square" rtlCol="0" anchor="t"/>
           <a:lstStyle/>
           <a:p>
-            <a:pPr indent="0" marL="0">
+            <a:pPr marL="0" indent="0">
               <a:buNone/>
             </a:pPr>
             <a:r>
@@ -8763,7 +8530,7 @@
           <a:bodyPr wrap="square" rtlCol="0" anchor="ctr"/>
           <a:lstStyle/>
           <a:p>
-            <a:pPr indent="0" marL="0">
+            <a:pPr marL="0" indent="0">
               <a:buNone/>
             </a:pPr>
             <a:r>
@@ -8802,7 +8569,7 @@
           <a:bodyPr wrap="square" rtlCol="0" anchor="t"/>
           <a:lstStyle/>
           <a:p>
-            <a:pPr indent="0" marL="0">
+            <a:pPr marL="0" indent="0">
               <a:buNone/>
             </a:pPr>
             <a:r>
@@ -8888,7 +8655,7 @@
           <a:bodyPr wrap="square" rtlCol="0" anchor="ctr"/>
           <a:lstStyle/>
           <a:p>
-            <a:pPr indent="0" marL="0">
+            <a:pPr marL="0" indent="0">
               <a:buNone/>
             </a:pPr>
             <a:r>
@@ -8927,7 +8694,7 @@
           <a:bodyPr wrap="square" rtlCol="0" anchor="t"/>
           <a:lstStyle/>
           <a:p>
-            <a:pPr indent="0" marL="0">
+            <a:pPr marL="0" indent="0">
               <a:buNone/>
             </a:pPr>
             <a:r>
@@ -9013,7 +8780,7 @@
           <a:bodyPr wrap="square" rtlCol="0" anchor="ctr"/>
           <a:lstStyle/>
           <a:p>
-            <a:pPr indent="0" marL="0">
+            <a:pPr marL="0" indent="0">
               <a:buNone/>
             </a:pPr>
             <a:r>
@@ -9052,7 +8819,7 @@
           <a:bodyPr wrap="square" rtlCol="0" anchor="t"/>
           <a:lstStyle/>
           <a:p>
-            <a:pPr indent="0" marL="0">
+            <a:pPr marL="0" indent="0">
               <a:buNone/>
             </a:pPr>
             <a:r>
@@ -9138,7 +8905,7 @@
           <a:bodyPr wrap="square" rtlCol="0" anchor="ctr"/>
           <a:lstStyle/>
           <a:p>
-            <a:pPr indent="0" marL="0">
+            <a:pPr marL="0" indent="0">
               <a:buNone/>
             </a:pPr>
             <a:r>
@@ -9177,7 +8944,7 @@
           <a:bodyPr wrap="square" rtlCol="0" anchor="t"/>
           <a:lstStyle/>
           <a:p>
-            <a:pPr indent="0" marL="0">
+            <a:pPr marL="0" indent="0">
               <a:buNone/>
             </a:pPr>
             <a:r>
@@ -9263,7 +9030,7 @@
           <a:bodyPr wrap="square" rtlCol="0" anchor="ctr"/>
           <a:lstStyle/>
           <a:p>
-            <a:pPr indent="0" marL="0">
+            <a:pPr marL="0" indent="0">
               <a:buNone/>
             </a:pPr>
             <a:r>
@@ -9302,7 +9069,7 @@
           <a:bodyPr wrap="square" rtlCol="0" anchor="t"/>
           <a:lstStyle/>
           <a:p>
-            <a:pPr indent="0" marL="0">
+            <a:pPr marL="0" indent="0">
               <a:buNone/>
             </a:pPr>
             <a:r>
@@ -9388,7 +9155,7 @@
           <a:bodyPr wrap="square" rtlCol="0" anchor="ctr"/>
           <a:lstStyle/>
           <a:p>
-            <a:pPr indent="0" marL="0">
+            <a:pPr marL="0" indent="0">
               <a:buNone/>
             </a:pPr>
             <a:r>
@@ -9427,7 +9194,7 @@
           <a:bodyPr wrap="square" rtlCol="0" anchor="t"/>
           <a:lstStyle/>
           <a:p>
-            <a:pPr indent="0" marL="0">
+            <a:pPr marL="0" indent="0">
               <a:buNone/>
             </a:pPr>
             <a:r>
@@ -9513,7 +9280,7 @@
           <a:bodyPr wrap="square" rtlCol="0" anchor="ctr"/>
           <a:lstStyle/>
           <a:p>
-            <a:pPr indent="0" marL="0">
+            <a:pPr marL="0" indent="0">
               <a:buNone/>
             </a:pPr>
             <a:r>
@@ -9552,7 +9319,7 @@
           <a:bodyPr wrap="square" rtlCol="0" anchor="t"/>
           <a:lstStyle/>
           <a:p>
-            <a:pPr indent="0" marL="0">
+            <a:pPr marL="0" indent="0">
               <a:buNone/>
             </a:pPr>
             <a:r>
@@ -9618,7 +9385,7 @@
           <a:bodyPr wrap="square" rtlCol="0" anchor="ctr"/>
           <a:lstStyle/>
           <a:p>
-            <a:pPr algn="ctr" indent="0" marL="0">
+            <a:pPr marL="0" indent="0" algn="ctr">
               <a:buNone/>
             </a:pPr>
             <a:r>
@@ -9677,7 +9444,7 @@
           <a:bodyPr wrap="square" rtlCol="0" anchor="ctr"/>
           <a:lstStyle/>
           <a:p>
-            <a:pPr algn="l" indent="0" marL="0">
+            <a:pPr marL="0" indent="0" algn="l">
               <a:buNone/>
             </a:pPr>
             <a:r>
@@ -9716,7 +9483,7 @@
           <a:bodyPr wrap="square" rtlCol="0" anchor="ctr"/>
           <a:lstStyle/>
           <a:p>
-            <a:pPr algn="r" indent="0" marL="0">
+            <a:pPr marL="0" indent="0" algn="r">
               <a:buNone/>
             </a:pPr>
             <a:r>
@@ -9750,6 +9517,7 @@
         <a:solidFill>
           <a:srgbClr val="07152D"/>
         </a:solidFill>
+        <a:effectLst/>
       </p:bgPr>
     </p:bg>
     <p:spTree>
@@ -9787,11 +9555,11 @@
           <a:bodyPr wrap="square" rtlCol="0" anchor="ctr"/>
           <a:lstStyle/>
           <a:p>
-            <a:pPr indent="0" marL="0">
-              <a:buNone/>
-            </a:pPr>
-            <a:r>
-              <a:rPr lang="en-US" sz="1100" b="1" spc="200" kern="0" dirty="0">
+            <a:pPr marL="0" indent="0">
+              <a:buNone/>
+            </a:pPr>
+            <a:r>
+              <a:rPr lang="en-US" sz="1100" b="1" kern="0" spc="200" dirty="0">
                 <a:solidFill>
                   <a:srgbClr val="F5A314"/>
                 </a:solidFill>
@@ -9826,7 +9594,7 @@
           <a:bodyPr wrap="square" rtlCol="0" anchor="ctr"/>
           <a:lstStyle/>
           <a:p>
-            <a:pPr indent="0" marL="0">
+            <a:pPr marL="0" indent="0">
               <a:buNone/>
             </a:pPr>
             <a:r>
@@ -9934,7 +9702,7 @@
           <a:bodyPr wrap="square" rtlCol="0" anchor="ctr"/>
           <a:lstStyle/>
           <a:p>
-            <a:pPr indent="0" marL="0">
+            <a:pPr marL="0" indent="0">
               <a:buNone/>
             </a:pPr>
             <a:r>
@@ -9973,7 +9741,7 @@
           <a:bodyPr wrap="square" rtlCol="0" anchor="t"/>
           <a:lstStyle/>
           <a:p>
-            <a:pPr indent="0" marL="0">
+            <a:pPr marL="0" indent="0">
               <a:buNone/>
             </a:pPr>
             <a:r>
@@ -10059,7 +9827,7 @@
           <a:bodyPr wrap="square" rtlCol="0" anchor="ctr"/>
           <a:lstStyle/>
           <a:p>
-            <a:pPr indent="0" marL="0">
+            <a:pPr marL="0" indent="0">
               <a:buNone/>
             </a:pPr>
             <a:r>
@@ -10098,7 +9866,7 @@
           <a:bodyPr wrap="square" rtlCol="0" anchor="t"/>
           <a:lstStyle/>
           <a:p>
-            <a:pPr indent="0" marL="0">
+            <a:pPr marL="0" indent="0">
               <a:buNone/>
             </a:pPr>
             <a:r>
@@ -10145,14 +9913,14 @@
       </p:sp>
       <p:pic>
         <p:nvPicPr>
-          <p:cNvPr id="14" name="Image 0" descr="C:/Users/ZBOOK/AppData/Local/Temp/kazi-deck/assets/shot-billing-crop.png">    </p:cNvPr>
+          <p:cNvPr id="14" name="Image 0" descr="C:/Users/ZBOOK/AppData/Local/Temp/kazi-deck/assets/shot-billing-crop.png"/>
           <p:cNvPicPr>
             <a:picLocks noChangeAspect="1"/>
           </p:cNvPicPr>
           <p:nvPr/>
         </p:nvPicPr>
         <p:blipFill>
-          <a:blip r:embed="rId1"/>
+          <a:blip r:embed="rId3"/>
           <a:stretch>
             <a:fillRect/>
           </a:stretch>
@@ -10215,7 +9983,7 @@
           <a:bodyPr wrap="square" rtlCol="0" anchor="ctr"/>
           <a:lstStyle/>
           <a:p>
-            <a:pPr indent="0" marL="0">
+            <a:pPr marL="0" indent="0">
               <a:buNone/>
             </a:pPr>
             <a:r>
@@ -10382,7 +10150,7 @@
           <a:bodyPr wrap="square" rtlCol="0" anchor="ctr"/>
           <a:lstStyle/>
           <a:p>
-            <a:pPr algn="ctr" indent="0" marL="0">
+            <a:pPr marL="0" indent="0" algn="ctr">
               <a:buNone/>
             </a:pPr>
             <a:r>
@@ -10441,7 +10209,7 @@
           <a:bodyPr wrap="square" rtlCol="0" anchor="ctr"/>
           <a:lstStyle/>
           <a:p>
-            <a:pPr algn="l" indent="0" marL="0">
+            <a:pPr marL="0" indent="0" algn="l">
               <a:buNone/>
             </a:pPr>
             <a:r>
@@ -10480,7 +10248,7 @@
           <a:bodyPr wrap="square" rtlCol="0" anchor="ctr"/>
           <a:lstStyle/>
           <a:p>
-            <a:pPr algn="r" indent="0" marL="0">
+            <a:pPr marL="0" indent="0" algn="r">
               <a:buNone/>
             </a:pPr>
             <a:r>
@@ -10514,6 +10282,7 @@
         <a:solidFill>
           <a:srgbClr val="07152D"/>
         </a:solidFill>
+        <a:effectLst/>
       </p:bgPr>
     </p:bg>
     <p:spTree>
@@ -10551,11 +10320,11 @@
           <a:bodyPr wrap="square" rtlCol="0" anchor="ctr"/>
           <a:lstStyle/>
           <a:p>
-            <a:pPr indent="0" marL="0">
-              <a:buNone/>
-            </a:pPr>
-            <a:r>
-              <a:rPr lang="en-US" sz="1100" b="1" spc="200" kern="0" dirty="0">
+            <a:pPr marL="0" indent="0">
+              <a:buNone/>
+            </a:pPr>
+            <a:r>
+              <a:rPr lang="en-US" sz="1100" b="1" kern="0" spc="200" dirty="0">
                 <a:solidFill>
                   <a:srgbClr val="F5A314"/>
                 </a:solidFill>
@@ -10590,7 +10359,7 @@
           <a:bodyPr wrap="square" rtlCol="0" anchor="ctr"/>
           <a:lstStyle/>
           <a:p>
-            <a:pPr indent="0" marL="0">
+            <a:pPr marL="0" indent="0">
               <a:buNone/>
             </a:pPr>
             <a:r>
@@ -10678,7 +10447,7 @@
           <a:bodyPr wrap="square" rtlCol="0" anchor="ctr"/>
           <a:lstStyle/>
           <a:p>
-            <a:pPr indent="0" marL="0">
+            <a:pPr marL="0" indent="0">
               <a:buNone/>
             </a:pPr>
             <a:r>
@@ -10737,7 +10506,7 @@
           <a:bodyPr wrap="square" rtlCol="0" anchor="t"/>
           <a:lstStyle/>
           <a:p>
-            <a:pPr indent="0" marL="0">
+            <a:pPr marL="0" indent="0">
               <a:buNone/>
             </a:pPr>
             <a:r>
@@ -10798,7 +10567,7 @@
           <a:bodyPr wrap="square" rtlCol="0" anchor="ctr"/>
           <a:lstStyle/>
           <a:p>
-            <a:pPr indent="0" marL="0">
+            <a:pPr marL="0" indent="0">
               <a:buNone/>
             </a:pPr>
             <a:r>
@@ -10857,7 +10626,7 @@
           <a:bodyPr wrap="square" rtlCol="0" anchor="t"/>
           <a:lstStyle/>
           <a:p>
-            <a:pPr indent="0" marL="0">
+            <a:pPr marL="0" indent="0">
               <a:buNone/>
             </a:pPr>
             <a:r>
@@ -10923,7 +10692,7 @@
           <a:bodyPr wrap="square" rtlCol="0" anchor="ctr"/>
           <a:lstStyle/>
           <a:p>
-            <a:pPr indent="0" marL="0">
+            <a:pPr marL="0" indent="0">
               <a:buNone/>
             </a:pPr>
             <a:r>
@@ -10982,7 +10751,7 @@
           <a:bodyPr wrap="square" rtlCol="0" anchor="t"/>
           <a:lstStyle/>
           <a:p>
-            <a:pPr indent="0" marL="0">
+            <a:pPr marL="0" indent="0">
               <a:buNone/>
             </a:pPr>
             <a:r>
@@ -11048,7 +10817,7 @@
           <a:bodyPr wrap="square" rtlCol="0" anchor="ctr"/>
           <a:lstStyle/>
           <a:p>
-            <a:pPr indent="0" marL="0">
+            <a:pPr marL="0" indent="0">
               <a:buNone/>
             </a:pPr>
             <a:r>
@@ -11192,7 +10961,7 @@
           <a:bodyPr wrap="square" rtlCol="0" anchor="ctr"/>
           <a:lstStyle/>
           <a:p>
-            <a:pPr algn="l" indent="0" marL="0">
+            <a:pPr marL="0" indent="0" algn="l">
               <a:buNone/>
             </a:pPr>
             <a:r>
@@ -11231,7 +11000,7 @@
           <a:bodyPr wrap="square" rtlCol="0" anchor="ctr"/>
           <a:lstStyle/>
           <a:p>
-            <a:pPr algn="r" indent="0" marL="0">
+            <a:pPr marL="0" indent="0" algn="r">
               <a:buNone/>
             </a:pPr>
             <a:r>
@@ -11265,6 +11034,7 @@
         <a:solidFill>
           <a:srgbClr val="07152D"/>
         </a:solidFill>
+        <a:effectLst/>
       </p:bgPr>
     </p:bg>
     <p:spTree>
@@ -11302,11 +11072,11 @@
           <a:bodyPr wrap="square" rtlCol="0" anchor="ctr"/>
           <a:lstStyle/>
           <a:p>
-            <a:pPr indent="0" marL="0">
-              <a:buNone/>
-            </a:pPr>
-            <a:r>
-              <a:rPr lang="en-US" sz="1100" b="1" spc="200" kern="0" dirty="0">
+            <a:pPr marL="0" indent="0">
+              <a:buNone/>
+            </a:pPr>
+            <a:r>
+              <a:rPr lang="en-US" sz="1100" b="1" kern="0" spc="200" dirty="0">
                 <a:solidFill>
                   <a:srgbClr val="F5A314"/>
                 </a:solidFill>
@@ -11341,7 +11111,7 @@
           <a:bodyPr wrap="square" rtlCol="0" anchor="ctr"/>
           <a:lstStyle/>
           <a:p>
-            <a:pPr indent="0" marL="0">
+            <a:pPr marL="0" indent="0">
               <a:buNone/>
             </a:pPr>
             <a:r>
@@ -11402,7 +11172,7 @@
           <a:bodyPr wrap="square" rtlCol="0" anchor="ctr"/>
           <a:lstStyle/>
           <a:p>
-            <a:pPr indent="0" marL="0">
+            <a:pPr marL="0" indent="0">
               <a:buNone/>
             </a:pPr>
             <a:r>
@@ -11488,7 +11258,7 @@
           <a:bodyPr wrap="square" rtlCol="0" anchor="ctr"/>
           <a:lstStyle/>
           <a:p>
-            <a:pPr indent="0" marL="0">
+            <a:pPr marL="0" indent="0">
               <a:buNone/>
             </a:pPr>
             <a:r>
@@ -11527,7 +11297,7 @@
           <a:bodyPr wrap="square" rtlCol="0" anchor="ctr"/>
           <a:lstStyle/>
           <a:p>
-            <a:pPr indent="0" marL="0">
+            <a:pPr marL="0" indent="0">
               <a:buNone/>
             </a:pPr>
             <a:r>
@@ -11613,7 +11383,7 @@
           <a:bodyPr wrap="square" rtlCol="0" anchor="ctr"/>
           <a:lstStyle/>
           <a:p>
-            <a:pPr indent="0" marL="0">
+            <a:pPr marL="0" indent="0">
               <a:buNone/>
             </a:pPr>
             <a:r>
@@ -11652,7 +11422,7 @@
           <a:bodyPr wrap="square" rtlCol="0" anchor="ctr"/>
           <a:lstStyle/>
           <a:p>
-            <a:pPr indent="0" marL="0">
+            <a:pPr marL="0" indent="0">
               <a:buNone/>
             </a:pPr>
             <a:r>
@@ -11738,7 +11508,7 @@
           <a:bodyPr wrap="square" rtlCol="0" anchor="ctr"/>
           <a:lstStyle/>
           <a:p>
-            <a:pPr indent="0" marL="0">
+            <a:pPr marL="0" indent="0">
               <a:buNone/>
             </a:pPr>
             <a:r>
@@ -11777,7 +11547,7 @@
           <a:bodyPr wrap="square" rtlCol="0" anchor="ctr"/>
           <a:lstStyle/>
           <a:p>
-            <a:pPr indent="0" marL="0">
+            <a:pPr marL="0" indent="0">
               <a:buNone/>
             </a:pPr>
             <a:r>
@@ -11863,7 +11633,7 @@
           <a:bodyPr wrap="square" rtlCol="0" anchor="ctr"/>
           <a:lstStyle/>
           <a:p>
-            <a:pPr indent="0" marL="0">
+            <a:pPr marL="0" indent="0">
               <a:buNone/>
             </a:pPr>
             <a:r>
@@ -11902,7 +11672,7 @@
           <a:bodyPr wrap="square" rtlCol="0" anchor="ctr"/>
           <a:lstStyle/>
           <a:p>
-            <a:pPr indent="0" marL="0">
+            <a:pPr marL="0" indent="0">
               <a:buNone/>
             </a:pPr>
             <a:r>
@@ -11968,7 +11738,7 @@
           <a:bodyPr wrap="square" rtlCol="0" anchor="ctr"/>
           <a:lstStyle/>
           <a:p>
-            <a:pPr indent="0" marL="0">
+            <a:pPr marL="0" indent="0">
               <a:buNone/>
             </a:pPr>
             <a:r>
@@ -12092,7 +11862,7 @@
           <a:bodyPr wrap="square" rtlCol="0" anchor="ctr"/>
           <a:lstStyle/>
           <a:p>
-            <a:pPr indent="0" marL="0">
+            <a:pPr marL="0" indent="0">
               <a:buNone/>
             </a:pPr>
             <a:r>
@@ -12236,7 +12006,7 @@
           <a:bodyPr wrap="square" rtlCol="0" anchor="ctr"/>
           <a:lstStyle/>
           <a:p>
-            <a:pPr algn="l" indent="0" marL="0">
+            <a:pPr marL="0" indent="0" algn="l">
               <a:buNone/>
             </a:pPr>
             <a:r>
@@ -12275,7 +12045,7 @@
           <a:bodyPr wrap="square" rtlCol="0" anchor="ctr"/>
           <a:lstStyle/>
           <a:p>
-            <a:pPr algn="r" indent="0" marL="0">
+            <a:pPr marL="0" indent="0" algn="r">
               <a:buNone/>
             </a:pPr>
             <a:r>
@@ -12309,6 +12079,7 @@
         <a:solidFill>
           <a:srgbClr val="07152D"/>
         </a:solidFill>
+        <a:effectLst/>
       </p:bgPr>
     </p:bg>
     <p:spTree>
@@ -12346,11 +12117,11 @@
           <a:bodyPr wrap="square" rtlCol="0" anchor="ctr"/>
           <a:lstStyle/>
           <a:p>
-            <a:pPr indent="0" marL="0">
-              <a:buNone/>
-            </a:pPr>
-            <a:r>
-              <a:rPr lang="en-US" sz="1100" b="1" spc="200" kern="0" dirty="0">
+            <a:pPr marL="0" indent="0">
+              <a:buNone/>
+            </a:pPr>
+            <a:r>
+              <a:rPr lang="en-US" sz="1100" b="1" kern="0" spc="200" dirty="0">
                 <a:solidFill>
                   <a:srgbClr val="F5A314"/>
                 </a:solidFill>
@@ -12385,7 +12156,7 @@
           <a:bodyPr wrap="square" rtlCol="0" anchor="ctr"/>
           <a:lstStyle/>
           <a:p>
-            <a:pPr indent="0" marL="0">
+            <a:pPr marL="0" indent="0">
               <a:buNone/>
             </a:pPr>
             <a:r>
@@ -12468,7 +12239,7 @@
           <a:bodyPr wrap="square" rtlCol="0" anchor="ctr"/>
           <a:lstStyle/>
           <a:p>
-            <a:pPr algn="ctr" indent="0" marL="0">
+            <a:pPr marL="0" indent="0" algn="ctr">
               <a:buNone/>
             </a:pPr>
             <a:r>
@@ -12529,7 +12300,7 @@
           <a:bodyPr wrap="square" rtlCol="0" anchor="ctr"/>
           <a:lstStyle/>
           <a:p>
-            <a:pPr algn="ctr" indent="0" marL="0">
+            <a:pPr marL="0" indent="0" algn="ctr">
               <a:buNone/>
             </a:pPr>
             <a:r>
@@ -12590,7 +12361,7 @@
           <a:bodyPr wrap="square" rtlCol="0" anchor="ctr"/>
           <a:lstStyle/>
           <a:p>
-            <a:pPr algn="ctr" indent="0" marL="0">
+            <a:pPr marL="0" indent="0" algn="ctr">
               <a:buNone/>
             </a:pPr>
             <a:r>
@@ -12651,7 +12422,7 @@
           <a:bodyPr wrap="square" rtlCol="0" anchor="ctr"/>
           <a:lstStyle/>
           <a:p>
-            <a:pPr algn="ctr" indent="0" marL="0">
+            <a:pPr marL="0" indent="0" algn="ctr">
               <a:buNone/>
             </a:pPr>
             <a:r>
@@ -12739,7 +12510,7 @@
           <a:bodyPr wrap="square" rtlCol="0" anchor="ctr"/>
           <a:lstStyle/>
           <a:p>
-            <a:pPr algn="ctr" indent="0" marL="0">
+            <a:pPr marL="0" indent="0" algn="ctr">
               <a:buNone/>
             </a:pPr>
             <a:r>
@@ -12996,7 +12767,7 @@
           <a:bodyPr wrap="square" rtlCol="0" anchor="ctr"/>
           <a:lstStyle/>
           <a:p>
-            <a:pPr algn="ctr" indent="0" marL="0">
+            <a:pPr marL="0" indent="0" algn="ctr">
               <a:buNone/>
             </a:pPr>
             <a:r>
@@ -13212,14 +12983,14 @@
       </p:sp>
       <p:pic>
         <p:nvPicPr>
-          <p:cNvPr id="22" name="Image 0" descr="C:/Users/ZBOOK/AppData/Local/Temp/kazi-deck/assets/shot-dashboard.png">    </p:cNvPr>
+          <p:cNvPr id="22" name="Image 0" descr="C:/Users/ZBOOK/AppData/Local/Temp/kazi-deck/assets/shot-dashboard.png"/>
           <p:cNvPicPr>
             <a:picLocks noChangeAspect="1"/>
           </p:cNvPicPr>
           <p:nvPr/>
         </p:nvPicPr>
         <p:blipFill>
-          <a:blip r:embed="rId1"/>
+          <a:blip r:embed="rId3"/>
           <a:stretch>
             <a:fillRect/>
           </a:stretch>
@@ -13282,7 +13053,7 @@
           <a:bodyPr wrap="square" rtlCol="0" anchor="ctr"/>
           <a:lstStyle/>
           <a:p>
-            <a:pPr indent="0" marL="0">
+            <a:pPr marL="0" indent="0">
               <a:buNone/>
             </a:pPr>
             <a:r>
@@ -13321,7 +13092,7 @@
           <a:bodyPr wrap="square" rtlCol="0" anchor="t"/>
           <a:lstStyle/>
           <a:p>
-            <a:pPr indent="0" marL="0">
+            <a:pPr marL="0" indent="0">
               <a:buNone/>
             </a:pPr>
             <a:r>
@@ -13380,7 +13151,7 @@
           <a:bodyPr wrap="square" rtlCol="0" anchor="ctr"/>
           <a:lstStyle/>
           <a:p>
-            <a:pPr algn="l" indent="0" marL="0">
+            <a:pPr marL="0" indent="0" algn="l">
               <a:buNone/>
             </a:pPr>
             <a:r>
@@ -13419,7 +13190,7 @@
           <a:bodyPr wrap="square" rtlCol="0" anchor="ctr"/>
           <a:lstStyle/>
           <a:p>
-            <a:pPr algn="r" indent="0" marL="0">
+            <a:pPr marL="0" indent="0" algn="r">
               <a:buNone/>
             </a:pPr>
             <a:r>
@@ -13738,4 +13509,265 @@
     </a:ext>
   </a:extLst>
 </a:theme>
+</file>
+
+<file path=ppt/theme/theme2.xml><?xml version="1.0" encoding="utf-8"?>
+<a:theme xmlns:a="http://schemas.openxmlformats.org/drawingml/2006/main" name="Office Theme">
+  <a:themeElements>
+    <a:clrScheme name="Office">
+      <a:dk1>
+        <a:sysClr val="windowText" lastClr="000000"/>
+      </a:dk1>
+      <a:lt1>
+        <a:sysClr val="window" lastClr="FFFFFF"/>
+      </a:lt1>
+      <a:dk2>
+        <a:srgbClr val="44546A"/>
+      </a:dk2>
+      <a:lt2>
+        <a:srgbClr val="E7E6E6"/>
+      </a:lt2>
+      <a:accent1>
+        <a:srgbClr val="5B9BD5"/>
+      </a:accent1>
+      <a:accent2>
+        <a:srgbClr val="ED7D31"/>
+      </a:accent2>
+      <a:accent3>
+        <a:srgbClr val="A5A5A5"/>
+      </a:accent3>
+      <a:accent4>
+        <a:srgbClr val="FFC000"/>
+      </a:accent4>
+      <a:accent5>
+        <a:srgbClr val="4472C4"/>
+      </a:accent5>
+      <a:accent6>
+        <a:srgbClr val="70AD47"/>
+      </a:accent6>
+      <a:hlink>
+        <a:srgbClr val="0563C1"/>
+      </a:hlink>
+      <a:folHlink>
+        <a:srgbClr val="954F72"/>
+      </a:folHlink>
+    </a:clrScheme>
+    <a:fontScheme name="Office">
+      <a:majorFont>
+        <a:latin typeface="Calibri Light" panose="020F0302020204030204"/>
+        <a:ea typeface=""/>
+        <a:cs typeface=""/>
+        <a:font script="Jpan" typeface="游ゴシック Light"/>
+        <a:font script="Hang" typeface="맑은 고딕"/>
+        <a:font script="Hans" typeface="等线 Light"/>
+        <a:font script="Hant" typeface="新細明體"/>
+        <a:font script="Arab" typeface="Times New Roman"/>
+        <a:font script="Hebr" typeface="Times New Roman"/>
+        <a:font script="Thai" typeface="Angsana New"/>
+        <a:font script="Ethi" typeface="Nyala"/>
+        <a:font script="Beng" typeface="Vrinda"/>
+        <a:font script="Gujr" typeface="Shruti"/>
+        <a:font script="Khmr" typeface="MoolBoran"/>
+        <a:font script="Knda" typeface="Tunga"/>
+        <a:font script="Guru" typeface="Raavi"/>
+        <a:font script="Cans" typeface="Euphemia"/>
+        <a:font script="Cher" typeface="Plantagenet Cherokee"/>
+        <a:font script="Yiii" typeface="Microsoft Yi Baiti"/>
+        <a:font script="Tibt" typeface="Microsoft Himalaya"/>
+        <a:font script="Thaa" typeface="MV Boli"/>
+        <a:font script="Deva" typeface="Mangal"/>
+        <a:font script="Telu" typeface="Gautami"/>
+        <a:font script="Taml" typeface="Latha"/>
+        <a:font script="Syrc" typeface="Estrangelo Edessa"/>
+        <a:font script="Orya" typeface="Kalinga"/>
+        <a:font script="Mlym" typeface="Kartika"/>
+        <a:font script="Laoo" typeface="DokChampa"/>
+        <a:font script="Sinh" typeface="Iskoola Pota"/>
+        <a:font script="Mong" typeface="Mongolian Baiti"/>
+        <a:font script="Viet" typeface="Times New Roman"/>
+        <a:font script="Uigh" typeface="Microsoft Uighur"/>
+        <a:font script="Geor" typeface="Sylfaen"/>
+      </a:majorFont>
+      <a:minorFont>
+        <a:latin typeface="Calibri" panose="020F0502020204030204"/>
+        <a:ea typeface=""/>
+        <a:cs typeface=""/>
+        <a:font script="Jpan" typeface="游ゴシック"/>
+        <a:font script="Hang" typeface="맑은 고딕"/>
+        <a:font script="Hans" typeface="等线"/>
+        <a:font script="Hant" typeface="新細明體"/>
+        <a:font script="Arab" typeface="Arial"/>
+        <a:font script="Hebr" typeface="Arial"/>
+        <a:font script="Thai" typeface="Cordia New"/>
+        <a:font script="Ethi" typeface="Nyala"/>
+        <a:font script="Beng" typeface="Vrinda"/>
+        <a:font script="Gujr" typeface="Shruti"/>
+        <a:font script="Khmr" typeface="DaunPenh"/>
+        <a:font script="Knda" typeface="Tunga"/>
+        <a:font script="Guru" typeface="Raavi"/>
+        <a:font script="Cans" typeface="Euphemia"/>
+        <a:font script="Cher" typeface="Plantagenet Cherokee"/>
+        <a:font script="Yiii" typeface="Microsoft Yi Baiti"/>
+        <a:font script="Tibt" typeface="Microsoft Himalaya"/>
+        <a:font script="Thaa" typeface="MV Boli"/>
+        <a:font script="Deva" typeface="Mangal"/>
+        <a:font script="Telu" typeface="Gautami"/>
+        <a:font script="Taml" typeface="Latha"/>
+        <a:font script="Syrc" typeface="Estrangelo Edessa"/>
+        <a:font script="Orya" typeface="Kalinga"/>
+        <a:font script="Mlym" typeface="Kartika"/>
+        <a:font script="Laoo" typeface="DokChampa"/>
+        <a:font script="Sinh" typeface="Iskoola Pota"/>
+        <a:font script="Mong" typeface="Mongolian Baiti"/>
+        <a:font script="Viet" typeface="Arial"/>
+        <a:font script="Uigh" typeface="Microsoft Uighur"/>
+        <a:font script="Geor" typeface="Sylfaen"/>
+      </a:minorFont>
+    </a:fontScheme>
+    <a:fmtScheme name="Office">
+      <a:fillStyleLst>
+        <a:solidFill>
+          <a:schemeClr val="phClr"/>
+        </a:solidFill>
+        <a:gradFill rotWithShape="1">
+          <a:gsLst>
+            <a:gs pos="0">
+              <a:schemeClr val="phClr">
+                <a:lumMod val="110000"/>
+                <a:satMod val="105000"/>
+                <a:tint val="67000"/>
+              </a:schemeClr>
+            </a:gs>
+            <a:gs pos="50000">
+              <a:schemeClr val="phClr">
+                <a:lumMod val="105000"/>
+                <a:satMod val="103000"/>
+                <a:tint val="73000"/>
+              </a:schemeClr>
+            </a:gs>
+            <a:gs pos="100000">
+              <a:schemeClr val="phClr">
+                <a:lumMod val="105000"/>
+                <a:satMod val="109000"/>
+                <a:tint val="81000"/>
+              </a:schemeClr>
+            </a:gs>
+          </a:gsLst>
+          <a:lin ang="5400000" scaled="0"/>
+        </a:gradFill>
+        <a:gradFill rotWithShape="1">
+          <a:gsLst>
+            <a:gs pos="0">
+              <a:schemeClr val="phClr">
+                <a:satMod val="103000"/>
+                <a:lumMod val="102000"/>
+                <a:tint val="94000"/>
+              </a:schemeClr>
+            </a:gs>
+            <a:gs pos="50000">
+              <a:schemeClr val="phClr">
+                <a:satMod val="110000"/>
+                <a:lumMod val="100000"/>
+                <a:shade val="100000"/>
+              </a:schemeClr>
+            </a:gs>
+            <a:gs pos="100000">
+              <a:schemeClr val="phClr">
+                <a:lumMod val="99000"/>
+                <a:satMod val="120000"/>
+                <a:shade val="78000"/>
+              </a:schemeClr>
+            </a:gs>
+          </a:gsLst>
+          <a:lin ang="5400000" scaled="0"/>
+        </a:gradFill>
+      </a:fillStyleLst>
+      <a:lnStyleLst>
+        <a:ln w="6350" cap="flat" cmpd="sng" algn="ctr">
+          <a:solidFill>
+            <a:schemeClr val="phClr"/>
+          </a:solidFill>
+          <a:prstDash val="solid"/>
+          <a:miter lim="800000"/>
+        </a:ln>
+        <a:ln w="12700" cap="flat" cmpd="sng" algn="ctr">
+          <a:solidFill>
+            <a:schemeClr val="phClr"/>
+          </a:solidFill>
+          <a:prstDash val="solid"/>
+          <a:miter lim="800000"/>
+        </a:ln>
+        <a:ln w="19050" cap="flat" cmpd="sng" algn="ctr">
+          <a:solidFill>
+            <a:schemeClr val="phClr"/>
+          </a:solidFill>
+          <a:prstDash val="solid"/>
+          <a:miter lim="800000"/>
+        </a:ln>
+      </a:lnStyleLst>
+      <a:effectStyleLst>
+        <a:effectStyle>
+          <a:effectLst/>
+        </a:effectStyle>
+        <a:effectStyle>
+          <a:effectLst/>
+        </a:effectStyle>
+        <a:effectStyle>
+          <a:effectLst>
+            <a:outerShdw blurRad="57150" dist="19050" dir="5400000" algn="ctr" rotWithShape="0">
+              <a:srgbClr val="000000">
+                <a:alpha val="63000"/>
+              </a:srgbClr>
+            </a:outerShdw>
+          </a:effectLst>
+        </a:effectStyle>
+      </a:effectStyleLst>
+      <a:bgFillStyleLst>
+        <a:solidFill>
+          <a:schemeClr val="phClr"/>
+        </a:solidFill>
+        <a:solidFill>
+          <a:schemeClr val="phClr">
+            <a:tint val="95000"/>
+            <a:satMod val="170000"/>
+          </a:schemeClr>
+        </a:solidFill>
+        <a:gradFill rotWithShape="1">
+          <a:gsLst>
+            <a:gs pos="0">
+              <a:schemeClr val="phClr">
+                <a:tint val="93000"/>
+                <a:satMod val="150000"/>
+                <a:shade val="98000"/>
+                <a:lumMod val="102000"/>
+              </a:schemeClr>
+            </a:gs>
+            <a:gs pos="50000">
+              <a:schemeClr val="phClr">
+                <a:tint val="98000"/>
+                <a:satMod val="130000"/>
+                <a:shade val="90000"/>
+                <a:lumMod val="103000"/>
+              </a:schemeClr>
+            </a:gs>
+            <a:gs pos="100000">
+              <a:schemeClr val="phClr">
+                <a:shade val="63000"/>
+                <a:satMod val="120000"/>
+              </a:schemeClr>
+            </a:gs>
+          </a:gsLst>
+          <a:lin ang="5400000" scaled="0"/>
+        </a:gradFill>
+      </a:bgFillStyleLst>
+    </a:fmtScheme>
+  </a:themeElements>
+  <a:objectDefaults/>
+  <a:extraClrSchemeLst/>
+  <a:extLst>
+    <a:ext uri="{05A4C25C-085E-4340-85A3-A5531E510DB2}">
+      <thm15:themeFamily xmlns:thm15="http://schemas.microsoft.com/office/thememl/2012/main" name="Office Theme" id="{62F939B6-93AF-4DB8-9C6B-D6C7DFDC589F}" vid="{4A3C46E8-61CC-4603-A589-7422A47A8E4A}"/>
+    </a:ext>
+  </a:extLst>
+</a:theme>
 </file>
</xml_diff>